<commit_message>
Serve corrected user guide as PDF
</commit_message>
<xml_diff>
--- a/docs/TAP_빠른사용가이드_v3.pptx
+++ b/docs/TAP_빠른사용가이드_v3.pptx
@@ -2,24 +2,24 @@
 <file path=ppt/presentation.xml><?xml version="1.0" encoding="utf-8"?>
 <p:presentation xmlns:p="http://schemas.openxmlformats.org/presentationml/2006/main">
   <p:sldMasterIdLst>
-    <p:sldMasterId xmlns:r="http://schemas.openxmlformats.org/officeDocument/2006/relationships" id="2147483648" r:id="R47d7b0cd20e24817"/>
+    <p:sldMasterId xmlns:r="http://schemas.openxmlformats.org/officeDocument/2006/relationships" id="2147483648" r:id="Rdd4b9f2597f4453e"/>
   </p:sldMasterIdLst>
   <p:notesMasterIdLst>
-    <p:notesMasterId xmlns:r="http://schemas.openxmlformats.org/officeDocument/2006/relationships" r:id="R9c95fd16123c4a9d"/>
+    <p:notesMasterId xmlns:r="http://schemas.openxmlformats.org/officeDocument/2006/relationships" r:id="R007a536964cd434e"/>
   </p:notesMasterIdLst>
   <p:sldIdLst>
-    <p:sldId xmlns:r="http://schemas.openxmlformats.org/officeDocument/2006/relationships" id="256" r:id="R523f36b761ba447c"/>
-    <p:sldId xmlns:r="http://schemas.openxmlformats.org/officeDocument/2006/relationships" id="257" r:id="R13e6180d5c0a406b"/>
-    <p:sldId xmlns:r="http://schemas.openxmlformats.org/officeDocument/2006/relationships" id="258" r:id="R6d06644605bf45ea"/>
-    <p:sldId xmlns:r="http://schemas.openxmlformats.org/officeDocument/2006/relationships" id="259" r:id="R634fee6bc5304818"/>
-    <p:sldId xmlns:r="http://schemas.openxmlformats.org/officeDocument/2006/relationships" id="260" r:id="R2e5c88a55e8d44fb"/>
-    <p:sldId xmlns:r="http://schemas.openxmlformats.org/officeDocument/2006/relationships" id="261" r:id="R1cce14b27b7b4e92"/>
-    <p:sldId xmlns:r="http://schemas.openxmlformats.org/officeDocument/2006/relationships" id="262" r:id="Raceddae9e01f4853"/>
-    <p:sldId xmlns:r="http://schemas.openxmlformats.org/officeDocument/2006/relationships" id="263" r:id="R836c7ccf32c748b7"/>
-    <p:sldId xmlns:r="http://schemas.openxmlformats.org/officeDocument/2006/relationships" id="264" r:id="R709a1ce35c0246b1"/>
-    <p:sldId xmlns:r="http://schemas.openxmlformats.org/officeDocument/2006/relationships" id="265" r:id="R3fe15bd2319f4235"/>
-    <p:sldId xmlns:r="http://schemas.openxmlformats.org/officeDocument/2006/relationships" id="266" r:id="R63e89965fa6f4914"/>
-    <p:sldId xmlns:r="http://schemas.openxmlformats.org/officeDocument/2006/relationships" id="267" r:id="R86017cf4505f4c98"/>
+    <p:sldId xmlns:r="http://schemas.openxmlformats.org/officeDocument/2006/relationships" id="256" r:id="R8c3e41d15baa4310"/>
+    <p:sldId xmlns:r="http://schemas.openxmlformats.org/officeDocument/2006/relationships" id="257" r:id="R19d0fcb31ff040de"/>
+    <p:sldId xmlns:r="http://schemas.openxmlformats.org/officeDocument/2006/relationships" id="258" r:id="R9476e9e87c7448f1"/>
+    <p:sldId xmlns:r="http://schemas.openxmlformats.org/officeDocument/2006/relationships" id="259" r:id="Rfd4ab9cd14d64044"/>
+    <p:sldId xmlns:r="http://schemas.openxmlformats.org/officeDocument/2006/relationships" id="260" r:id="R2246520730cc41b2"/>
+    <p:sldId xmlns:r="http://schemas.openxmlformats.org/officeDocument/2006/relationships" id="261" r:id="R4dd203cbd5b74dd3"/>
+    <p:sldId xmlns:r="http://schemas.openxmlformats.org/officeDocument/2006/relationships" id="262" r:id="Rbfd58fa392444d5b"/>
+    <p:sldId xmlns:r="http://schemas.openxmlformats.org/officeDocument/2006/relationships" id="263" r:id="R79470ac2d97945ff"/>
+    <p:sldId xmlns:r="http://schemas.openxmlformats.org/officeDocument/2006/relationships" id="264" r:id="R3a0bd71aafe74451"/>
+    <p:sldId xmlns:r="http://schemas.openxmlformats.org/officeDocument/2006/relationships" id="265" r:id="R74618910a8ed444d"/>
+    <p:sldId xmlns:r="http://schemas.openxmlformats.org/officeDocument/2006/relationships" id="266" r:id="R34dd654dfbc543cf"/>
+    <p:sldId xmlns:r="http://schemas.openxmlformats.org/officeDocument/2006/relationships" id="267" r:id="Re3179f797ee14463"/>
   </p:sldIdLst>
   <p:sldSz cx="18288000" cy="10287000"/>
   <p:notesSz cx="6858000" cy="9144000"/>
@@ -1694,8 +1694,8 @@
   </p:cSld>
   <p:clrMap bg1="lt1" tx1="dk1" bg2="lt2" tx2="dk2" accent1="accent1" accent2="accent2" accent3="accent3" accent4="accent4" accent5="accent5" accent6="accent6" hlink="hlink" folHlink="folHlink"/>
   <p:sldLayoutIdLst>
-    <p:sldLayoutId xmlns:r="http://schemas.openxmlformats.org/officeDocument/2006/relationships" id="2147483649" r:id="Ra1117aec06054acc"/>
-    <p:sldLayoutId xmlns:r="http://schemas.openxmlformats.org/officeDocument/2006/relationships" id="2147483650" r:id="Ra898f0a221d647e2"/>
+    <p:sldLayoutId xmlns:r="http://schemas.openxmlformats.org/officeDocument/2006/relationships" id="2147483649" r:id="R9ef68fcd43914285"/>
+    <p:sldLayoutId xmlns:r="http://schemas.openxmlformats.org/officeDocument/2006/relationships" id="2147483650" r:id="Rf14f6069e8c543ab"/>
   </p:sldLayoutIdLst>
   <p:hf sldNum="0" hdr="0" ftr="0" dt="0"/>
   <p:txStyles>
@@ -2224,7 +2224,7 @@
           <p:nvPr/>
         </p:nvPicPr>
         <p:blipFill>
-          <a:blip xmlns:r="http://schemas.openxmlformats.org/officeDocument/2006/relationships" xmlns:a="http://schemas.openxmlformats.org/drawingml/2006/main" r:embed="R149d2ef06e334ed4"/>
+          <a:blip xmlns:r="http://schemas.openxmlformats.org/officeDocument/2006/relationships" xmlns:a="http://schemas.openxmlformats.org/drawingml/2006/main" r:embed="R8b66cbf3fd244cf8"/>
           <a:srcRect xmlns:a="http://schemas.openxmlformats.org/drawingml/2006/main" l="0" t="-400" r="0" b="-400"/>
           <a:stretch xmlns:a="http://schemas.openxmlformats.org/drawingml/2006/main"/>
         </p:blipFill>
@@ -2247,7 +2247,7 @@
           <p:nvPr/>
         </p:nvPicPr>
         <p:blipFill>
-          <a:blip xmlns:r="http://schemas.openxmlformats.org/officeDocument/2006/relationships" xmlns:a="http://schemas.openxmlformats.org/drawingml/2006/main" r:embed="Rea4e4272e9dc40fb"/>
+          <a:blip xmlns:r="http://schemas.openxmlformats.org/officeDocument/2006/relationships" xmlns:a="http://schemas.openxmlformats.org/drawingml/2006/main" r:embed="R63fd2bcca4a74942"/>
           <a:srcRect xmlns:a="http://schemas.openxmlformats.org/drawingml/2006/main" l="-2083" t="0" r="-2083" b="0"/>
           <a:stretch xmlns:a="http://schemas.openxmlformats.org/drawingml/2006/main"/>
         </p:blipFill>
@@ -2503,7 +2503,7 @@
                 <a:ea typeface="페이퍼로지 3 Light"/>
                 <a:cs typeface="페이퍼로지 3 Light"/>
               </a:rPr>
-              <a:t>교육담당자 · 임직원 · KMA 운영자  |  2026.08</a:t>
+              <a:t>교육담당자 · 참여자 · KMA 관리자  |  2026.08</a:t>
             </a:r>
           </a:p>
         </p:txBody>
@@ -2880,7 +2880,7 @@
           <p:nvPr/>
         </p:nvPicPr>
         <p:blipFill>
-          <a:blip xmlns:r="http://schemas.openxmlformats.org/officeDocument/2006/relationships" xmlns:a="http://schemas.openxmlformats.org/drawingml/2006/main" r:embed="Rdb4d5f894d014aed"/>
+          <a:blip xmlns:r="http://schemas.openxmlformats.org/officeDocument/2006/relationships" xmlns:a="http://schemas.openxmlformats.org/drawingml/2006/main" r:embed="R5a0fec5106b44346"/>
           <a:srcRect xmlns:a="http://schemas.openxmlformats.org/drawingml/2006/main" l="-2083" t="0" r="-2083" b="0"/>
           <a:stretch xmlns:a="http://schemas.openxmlformats.org/drawingml/2006/main"/>
         </p:blipFill>
@@ -3003,7 +3003,7 @@
                 <a:ea typeface="페이퍼로지 4 Regular"/>
                 <a:cs typeface="페이퍼로지 4 Regular"/>
               </a:rPr>
-              <a:t>KMA OPERATOR</a:t>
+              <a:t>KMA ADMIN</a:t>
             </a:r>
           </a:p>
         </p:txBody>
@@ -3058,7 +3058,7 @@
                 <a:ea typeface="페이퍼로지 2 ExtraLight"/>
                 <a:cs typeface="페이퍼로지 2 ExtraLight"/>
               </a:rPr>
-              <a:t>KMA 운영자는 회원사 점수가 아니라</a:t>
+              <a:t>KMA 관리자는 회원사 점수가 아니라</a:t>
             </a:r>
           </a:p>
           <a:p xmlns:a="http://schemas.openxmlformats.org/drawingml/2006/main">
@@ -4285,14 +4285,13 @@
           <p:nvPr/>
         </p:nvPicPr>
         <p:blipFill>
-          <a:blip xmlns:r="http://schemas.openxmlformats.org/officeDocument/2006/relationships" xmlns:a="http://schemas.openxmlformats.org/drawingml/2006/main" r:embed="R190382fa3168429f"/>
-          <a:srcRect xmlns:a="http://schemas.openxmlformats.org/drawingml/2006/main" l="0" t="0" r="0" b="0"/>
+          <a:blip xmlns:r="http://schemas.openxmlformats.org/officeDocument/2006/relationships" xmlns:a="http://schemas.openxmlformats.org/drawingml/2006/main" r:embed="Rda5a4f580adb4ec1"/>
           <a:stretch xmlns:a="http://schemas.openxmlformats.org/drawingml/2006/main"/>
         </p:blipFill>
         <p:spPr>
           <a:xfrm xmlns:a="http://schemas.openxmlformats.org/drawingml/2006/main" flipH="0" flipV="0">
-            <a:off x="10668286" y="2095786"/>
-            <a:ext cx="6096286" cy="6476714"/>
+            <a:off x="10668286" y="3619563"/>
+            <a:ext cx="6096286" cy="3429161"/>
           </a:xfrm>
           <a:prstGeom xmlns:a="http://schemas.openxmlformats.org/drawingml/2006/main" prst="rect">
             <a:avLst/>
@@ -4330,7 +4329,7 @@
           <p:nvPr/>
         </p:nvPicPr>
         <p:blipFill>
-          <a:blip xmlns:r="http://schemas.openxmlformats.org/officeDocument/2006/relationships" xmlns:a="http://schemas.openxmlformats.org/drawingml/2006/main" r:embed="R3447d6523fee4099"/>
+          <a:blip xmlns:r="http://schemas.openxmlformats.org/officeDocument/2006/relationships" xmlns:a="http://schemas.openxmlformats.org/drawingml/2006/main" r:embed="Rb9857adf456847db"/>
           <a:srcRect xmlns:a="http://schemas.openxmlformats.org/drawingml/2006/main" l="-2083" t="0" r="-2083" b="0"/>
           <a:stretch xmlns:a="http://schemas.openxmlformats.org/drawingml/2006/main"/>
         </p:blipFill>
@@ -6179,7 +6178,7 @@
           <p:nvPr/>
         </p:nvPicPr>
         <p:blipFill>
-          <a:blip xmlns:r="http://schemas.openxmlformats.org/officeDocument/2006/relationships" xmlns:a="http://schemas.openxmlformats.org/drawingml/2006/main" r:embed="R004203f6e8ef4519"/>
+          <a:blip xmlns:r="http://schemas.openxmlformats.org/officeDocument/2006/relationships" xmlns:a="http://schemas.openxmlformats.org/drawingml/2006/main" r:embed="Rcba93933f45a420e"/>
           <a:srcRect xmlns:a="http://schemas.openxmlformats.org/drawingml/2006/main" l="-2083" t="0" r="-2083" b="0"/>
           <a:stretch xmlns:a="http://schemas.openxmlformats.org/drawingml/2006/main"/>
         </p:blipFill>
@@ -6202,7 +6201,7 @@
           <p:nvPr/>
         </p:nvPicPr>
         <p:blipFill>
-          <a:blip xmlns:r="http://schemas.openxmlformats.org/officeDocument/2006/relationships" xmlns:a="http://schemas.openxmlformats.org/drawingml/2006/main" r:embed="R79a2c0c0755b47f3"/>
+          <a:blip xmlns:r="http://schemas.openxmlformats.org/officeDocument/2006/relationships" xmlns:a="http://schemas.openxmlformats.org/drawingml/2006/main" r:embed="Rf0e10247930a4925"/>
           <a:srcRect xmlns:a="http://schemas.openxmlformats.org/drawingml/2006/main" l="-2083" t="0" r="-2083" b="0"/>
           <a:stretch xmlns:a="http://schemas.openxmlformats.org/drawingml/2006/main"/>
         </p:blipFill>
@@ -7097,7 +7096,7 @@
                 <a:ea typeface="페이퍼로지 5 Medium"/>
                 <a:cs typeface="페이퍼로지 5 Medium"/>
               </a:rPr>
-              <a:t>임직원</a:t>
+              <a:t>참여자</a:t>
             </a:r>
           </a:p>
         </p:txBody>
@@ -7207,7 +7206,7 @@
                 <a:ea typeface="페이퍼로지 5 Medium"/>
                 <a:cs typeface="페이퍼로지 5 Medium"/>
               </a:rPr>
-              <a:t>KMA 운영자</a:t>
+              <a:t>KMA 관리자</a:t>
             </a:r>
           </a:p>
         </p:txBody>
@@ -7812,7 +7811,7 @@
           <p:nvPr/>
         </p:nvPicPr>
         <p:blipFill>
-          <a:blip xmlns:r="http://schemas.openxmlformats.org/officeDocument/2006/relationships" xmlns:a="http://schemas.openxmlformats.org/drawingml/2006/main" r:embed="R2f97aae613b245cd"/>
+          <a:blip xmlns:r="http://schemas.openxmlformats.org/officeDocument/2006/relationships" xmlns:a="http://schemas.openxmlformats.org/drawingml/2006/main" r:embed="R44be7d70bd5a43e5"/>
           <a:srcRect xmlns:a="http://schemas.openxmlformats.org/drawingml/2006/main" l="-2083" t="0" r="-2083" b="0"/>
           <a:stretch xmlns:a="http://schemas.openxmlformats.org/drawingml/2006/main"/>
         </p:blipFill>
@@ -8908,7 +8907,7 @@
           <p:nvPr/>
         </p:nvPicPr>
         <p:blipFill>
-          <a:blip xmlns:r="http://schemas.openxmlformats.org/officeDocument/2006/relationships" xmlns:a="http://schemas.openxmlformats.org/drawingml/2006/main" r:embed="R0d127a8be3db486e"/>
+          <a:blip xmlns:r="http://schemas.openxmlformats.org/officeDocument/2006/relationships" xmlns:a="http://schemas.openxmlformats.org/drawingml/2006/main" r:embed="Rb426ffc7a2f7421f"/>
           <a:srcRect xmlns:a="http://schemas.openxmlformats.org/drawingml/2006/main" l="-2083" t="0" r="-2083" b="0"/>
           <a:stretch xmlns:a="http://schemas.openxmlformats.org/drawingml/2006/main"/>
         </p:blipFill>
@@ -9414,7 +9413,7 @@
                 <a:ea typeface="페이퍼로지 5 Medium"/>
                 <a:cs typeface="페이퍼로지 5 Medium"/>
               </a:rPr>
-              <a:t>임직원</a:t>
+              <a:t>참여자</a:t>
             </a:r>
           </a:p>
         </p:txBody>
@@ -9579,7 +9578,7 @@
                 <a:ea typeface="페이퍼로지 5 Medium"/>
                 <a:cs typeface="페이퍼로지 5 Medium"/>
               </a:rPr>
-              <a:t>KMA 운영자</a:t>
+              <a:t>KMA 관리자</a:t>
             </a:r>
           </a:p>
         </p:txBody>
@@ -10220,7 +10219,7 @@
                 <a:ea typeface="페이퍼로지 5 Medium"/>
                 <a:cs typeface="페이퍼로지 5 Medium"/>
               </a:rPr>
-              <a:t>임직원</a:t>
+              <a:t>참여자</a:t>
             </a:r>
           </a:p>
           <a:p xmlns:a="http://schemas.openxmlformats.org/drawingml/2006/main">
@@ -10313,7 +10312,7 @@
                 <a:ea typeface="페이퍼로지 5 Medium"/>
                 <a:cs typeface="페이퍼로지 5 Medium"/>
               </a:rPr>
-              <a:t>KMA 운영자</a:t>
+              <a:t>KMA 관리자</a:t>
             </a:r>
           </a:p>
           <a:p xmlns:a="http://schemas.openxmlformats.org/drawingml/2006/main">
@@ -10597,7 +10596,7 @@
                 <a:ea typeface="페이퍼로지 5 Medium"/>
                 <a:cs typeface="페이퍼로지 5 Medium"/>
               </a:rPr>
-              <a:t>교육담당자 · 임직원</a:t>
+              <a:t>교육담당자 · 참여자</a:t>
             </a:r>
           </a:p>
         </p:txBody>
@@ -10790,7 +10789,7 @@
           <p:nvPr/>
         </p:nvPicPr>
         <p:blipFill>
-          <a:blip xmlns:r="http://schemas.openxmlformats.org/officeDocument/2006/relationships" xmlns:a="http://schemas.openxmlformats.org/drawingml/2006/main" r:embed="R44588bdd076a431e"/>
+          <a:blip xmlns:r="http://schemas.openxmlformats.org/officeDocument/2006/relationships" xmlns:a="http://schemas.openxmlformats.org/drawingml/2006/main" r:embed="R5960ab507f124d85"/>
           <a:srcRect xmlns:a="http://schemas.openxmlformats.org/drawingml/2006/main" l="-2083" t="0" r="-2083" b="0"/>
           <a:stretch xmlns:a="http://schemas.openxmlformats.org/drawingml/2006/main"/>
         </p:blipFill>
@@ -13022,7 +13021,7 @@
           <p:nvPr/>
         </p:nvPicPr>
         <p:blipFill>
-          <a:blip xmlns:r="http://schemas.openxmlformats.org/officeDocument/2006/relationships" xmlns:a="http://schemas.openxmlformats.org/drawingml/2006/main" r:embed="R713834ef305a4c4a"/>
+          <a:blip xmlns:r="http://schemas.openxmlformats.org/officeDocument/2006/relationships" xmlns:a="http://schemas.openxmlformats.org/drawingml/2006/main" r:embed="Raa6cbfdf2be24b93"/>
           <a:srcRect xmlns:a="http://schemas.openxmlformats.org/drawingml/2006/main" l="-2083" t="0" r="-2083" b="0"/>
           <a:stretch xmlns:a="http://schemas.openxmlformats.org/drawingml/2006/main"/>
         </p:blipFill>
@@ -14769,7 +14768,7 @@
           <p:nvPr/>
         </p:nvPicPr>
         <p:blipFill>
-          <a:blip xmlns:r="http://schemas.openxmlformats.org/officeDocument/2006/relationships" xmlns:a="http://schemas.openxmlformats.org/drawingml/2006/main" r:embed="Rce9aedef239a47bb"/>
+          <a:blip xmlns:r="http://schemas.openxmlformats.org/officeDocument/2006/relationships" xmlns:a="http://schemas.openxmlformats.org/drawingml/2006/main" r:embed="R2a41ddb894634187"/>
           <a:srcRect xmlns:a="http://schemas.openxmlformats.org/drawingml/2006/main" l="-2083" t="0" r="-2083" b="0"/>
           <a:stretch xmlns:a="http://schemas.openxmlformats.org/drawingml/2006/main"/>
         </p:blipFill>
@@ -14792,7 +14791,7 @@
           <p:nvPr/>
         </p:nvPicPr>
         <p:blipFill>
-          <a:blip xmlns:r="http://schemas.openxmlformats.org/officeDocument/2006/relationships" xmlns:a="http://schemas.openxmlformats.org/drawingml/2006/main" r:embed="Rda2b6472142e47ba"/>
+          <a:blip xmlns:r="http://schemas.openxmlformats.org/officeDocument/2006/relationships" xmlns:a="http://schemas.openxmlformats.org/drawingml/2006/main" r:embed="Rabe3cf17e7e843c1"/>
           <a:srcRect xmlns:a="http://schemas.openxmlformats.org/drawingml/2006/main" l="-2083" t="0" r="-2083" b="0"/>
           <a:stretch xmlns:a="http://schemas.openxmlformats.org/drawingml/2006/main"/>
         </p:blipFill>
@@ -16594,7 +16593,7 @@
                 <a:ea typeface="페이퍼로지 6 SemiBold"/>
                 <a:cs typeface="페이퍼로지 6 SemiBold"/>
               </a:rPr>
-              <a:t>임직원</a:t>
+              <a:t>참여자</a:t>
             </a:r>
           </a:p>
         </p:txBody>
@@ -16910,7 +16909,7 @@
           <p:nvPr/>
         </p:nvPicPr>
         <p:blipFill>
-          <a:blip xmlns:r="http://schemas.openxmlformats.org/officeDocument/2006/relationships" xmlns:a="http://schemas.openxmlformats.org/drawingml/2006/main" r:embed="R035b710158074e70"/>
+          <a:blip xmlns:r="http://schemas.openxmlformats.org/officeDocument/2006/relationships" xmlns:a="http://schemas.openxmlformats.org/drawingml/2006/main" r:embed="Rc914676c7b004d72"/>
           <a:srcRect xmlns:a="http://schemas.openxmlformats.org/drawingml/2006/main" l="-2083" t="0" r="-2083" b="0"/>
           <a:stretch xmlns:a="http://schemas.openxmlformats.org/drawingml/2006/main"/>
         </p:blipFill>
@@ -18315,14 +18314,13 @@
           <p:nvPr/>
         </p:nvPicPr>
         <p:blipFill>
-          <a:blip xmlns:r="http://schemas.openxmlformats.org/officeDocument/2006/relationships" xmlns:a="http://schemas.openxmlformats.org/drawingml/2006/main" r:embed="R96ca6e6c33964ddc"/>
-          <a:srcRect xmlns:a="http://schemas.openxmlformats.org/drawingml/2006/main" l="0" t="0" r="0" b="0"/>
+          <a:blip xmlns:r="http://schemas.openxmlformats.org/officeDocument/2006/relationships" xmlns:a="http://schemas.openxmlformats.org/drawingml/2006/main" r:embed="R9fb51371cb8a4a95"/>
           <a:stretch xmlns:a="http://schemas.openxmlformats.org/drawingml/2006/main"/>
         </p:blipFill>
         <p:spPr>
           <a:xfrm xmlns:a="http://schemas.openxmlformats.org/drawingml/2006/main" flipH="0" flipV="0">
-            <a:off x="10668286" y="2095786"/>
-            <a:ext cx="6096286" cy="6476714"/>
+            <a:off x="10668286" y="3619563"/>
+            <a:ext cx="6096286" cy="3429161"/>
           </a:xfrm>
           <a:prstGeom xmlns:a="http://schemas.openxmlformats.org/drawingml/2006/main" prst="rect">
             <a:avLst/>
@@ -18452,7 +18450,7 @@
           <p:nvPr/>
         </p:nvPicPr>
         <p:blipFill>
-          <a:blip xmlns:r="http://schemas.openxmlformats.org/officeDocument/2006/relationships" xmlns:a="http://schemas.openxmlformats.org/drawingml/2006/main" r:embed="Rca477bb39e924d80"/>
+          <a:blip xmlns:r="http://schemas.openxmlformats.org/officeDocument/2006/relationships" xmlns:a="http://schemas.openxmlformats.org/drawingml/2006/main" r:embed="R574484fa17064c01"/>
           <a:srcRect xmlns:a="http://schemas.openxmlformats.org/drawingml/2006/main" l="-2083" t="0" r="-2083" b="0"/>
           <a:stretch xmlns:a="http://schemas.openxmlformats.org/drawingml/2006/main"/>
         </p:blipFill>
@@ -18575,7 +18573,7 @@
                 <a:ea typeface="페이퍼로지 4 Regular"/>
                 <a:cs typeface="페이퍼로지 4 Regular"/>
               </a:rPr>
-              <a:t>EMPLOYEE</a:t>
+              <a:t>PARTICIPANT</a:t>
             </a:r>
           </a:p>
         </p:txBody>
@@ -18630,7 +18628,7 @@
                 <a:ea typeface="페이퍼로지 2 ExtraLight"/>
                 <a:cs typeface="페이퍼로지 2 ExtraLight"/>
               </a:rPr>
-              <a:t>임직원은 최근 8주 행동에</a:t>
+              <a:t>참여자는 최근 8주 행동에</a:t>
             </a:r>
           </a:p>
           <a:p xmlns:a="http://schemas.openxmlformats.org/drawingml/2006/main">
@@ -19857,14 +19855,13 @@
           <p:nvPr/>
         </p:nvPicPr>
         <p:blipFill>
-          <a:blip xmlns:r="http://schemas.openxmlformats.org/officeDocument/2006/relationships" xmlns:a="http://schemas.openxmlformats.org/drawingml/2006/main" r:embed="R81f45c1ede58446c"/>
-          <a:srcRect xmlns:a="http://schemas.openxmlformats.org/drawingml/2006/main" l="0" t="0" r="0" b="0"/>
+          <a:blip xmlns:r="http://schemas.openxmlformats.org/officeDocument/2006/relationships" xmlns:a="http://schemas.openxmlformats.org/drawingml/2006/main" r:embed="Rb6bfe1111c564dbd"/>
           <a:stretch xmlns:a="http://schemas.openxmlformats.org/drawingml/2006/main"/>
         </p:blipFill>
         <p:spPr>
           <a:xfrm xmlns:a="http://schemas.openxmlformats.org/drawingml/2006/main" flipH="0" flipV="0">
-            <a:off x="10668286" y="2095786"/>
-            <a:ext cx="6096286" cy="6476714"/>
+            <a:off x="10668286" y="3619563"/>
+            <a:ext cx="6096286" cy="3429161"/>
           </a:xfrm>
           <a:prstGeom xmlns:a="http://schemas.openxmlformats.org/drawingml/2006/main" prst="rect">
             <a:avLst/>
@@ -19994,7 +19991,7 @@
           <p:nvPr/>
         </p:nvPicPr>
         <p:blipFill>
-          <a:blip xmlns:r="http://schemas.openxmlformats.org/officeDocument/2006/relationships" xmlns:a="http://schemas.openxmlformats.org/drawingml/2006/main" r:embed="R296d34cb36a2496b"/>
+          <a:blip xmlns:r="http://schemas.openxmlformats.org/officeDocument/2006/relationships" xmlns:a="http://schemas.openxmlformats.org/drawingml/2006/main" r:embed="R16e42a8f67fe4656"/>
           <a:srcRect xmlns:a="http://schemas.openxmlformats.org/drawingml/2006/main" l="-2083" t="0" r="-2083" b="0"/>
           <a:stretch xmlns:a="http://schemas.openxmlformats.org/drawingml/2006/main"/>
         </p:blipFill>
@@ -21399,14 +21396,13 @@
           <p:nvPr/>
         </p:nvPicPr>
         <p:blipFill>
-          <a:blip xmlns:r="http://schemas.openxmlformats.org/officeDocument/2006/relationships" xmlns:a="http://schemas.openxmlformats.org/drawingml/2006/main" r:embed="R044a0f5e892a45e3"/>
-          <a:srcRect xmlns:a="http://schemas.openxmlformats.org/drawingml/2006/main" l="0" t="0" r="0" b="0"/>
+          <a:blip xmlns:r="http://schemas.openxmlformats.org/officeDocument/2006/relationships" xmlns:a="http://schemas.openxmlformats.org/drawingml/2006/main" r:embed="R9a4cf989df00426e"/>
           <a:stretch xmlns:a="http://schemas.openxmlformats.org/drawingml/2006/main"/>
         </p:blipFill>
         <p:spPr>
           <a:xfrm xmlns:a="http://schemas.openxmlformats.org/drawingml/2006/main" flipH="0" flipV="0">
-            <a:off x="10668286" y="2095786"/>
-            <a:ext cx="6096286" cy="6476714"/>
+            <a:off x="10668286" y="3619563"/>
+            <a:ext cx="6096286" cy="3429161"/>
           </a:xfrm>
           <a:prstGeom xmlns:a="http://schemas.openxmlformats.org/drawingml/2006/main" prst="rect">
             <a:avLst/>

</xml_diff>

<commit_message>
feat: add pre-post training evaluation workflow
</commit_message>
<xml_diff>
--- a/docs/TAP_빠른사용가이드_v3.pptx
+++ b/docs/TAP_빠른사용가이드_v3.pptx
@@ -2,24 +2,24 @@
 <file path=ppt/presentation.xml><?xml version="1.0" encoding="utf-8"?>
 <p:presentation xmlns:p="http://schemas.openxmlformats.org/presentationml/2006/main">
   <p:sldMasterIdLst>
-    <p:sldMasterId xmlns:r="http://schemas.openxmlformats.org/officeDocument/2006/relationships" id="2147483648" r:id="Rdd4b9f2597f4453e"/>
+    <p:sldMasterId xmlns:r="http://schemas.openxmlformats.org/officeDocument/2006/relationships" id="2147483648" r:id="R3c820b1812384ccd"/>
   </p:sldMasterIdLst>
   <p:notesMasterIdLst>
-    <p:notesMasterId xmlns:r="http://schemas.openxmlformats.org/officeDocument/2006/relationships" r:id="R007a536964cd434e"/>
+    <p:notesMasterId xmlns:r="http://schemas.openxmlformats.org/officeDocument/2006/relationships" r:id="R4f2c9f174d1f4377"/>
   </p:notesMasterIdLst>
   <p:sldIdLst>
-    <p:sldId xmlns:r="http://schemas.openxmlformats.org/officeDocument/2006/relationships" id="256" r:id="R8c3e41d15baa4310"/>
-    <p:sldId xmlns:r="http://schemas.openxmlformats.org/officeDocument/2006/relationships" id="257" r:id="R19d0fcb31ff040de"/>
-    <p:sldId xmlns:r="http://schemas.openxmlformats.org/officeDocument/2006/relationships" id="258" r:id="R9476e9e87c7448f1"/>
-    <p:sldId xmlns:r="http://schemas.openxmlformats.org/officeDocument/2006/relationships" id="259" r:id="Rfd4ab9cd14d64044"/>
-    <p:sldId xmlns:r="http://schemas.openxmlformats.org/officeDocument/2006/relationships" id="260" r:id="R2246520730cc41b2"/>
-    <p:sldId xmlns:r="http://schemas.openxmlformats.org/officeDocument/2006/relationships" id="261" r:id="R4dd203cbd5b74dd3"/>
-    <p:sldId xmlns:r="http://schemas.openxmlformats.org/officeDocument/2006/relationships" id="262" r:id="Rbfd58fa392444d5b"/>
-    <p:sldId xmlns:r="http://schemas.openxmlformats.org/officeDocument/2006/relationships" id="263" r:id="R79470ac2d97945ff"/>
-    <p:sldId xmlns:r="http://schemas.openxmlformats.org/officeDocument/2006/relationships" id="264" r:id="R3a0bd71aafe74451"/>
-    <p:sldId xmlns:r="http://schemas.openxmlformats.org/officeDocument/2006/relationships" id="265" r:id="R74618910a8ed444d"/>
-    <p:sldId xmlns:r="http://schemas.openxmlformats.org/officeDocument/2006/relationships" id="266" r:id="R34dd654dfbc543cf"/>
-    <p:sldId xmlns:r="http://schemas.openxmlformats.org/officeDocument/2006/relationships" id="267" r:id="Re3179f797ee14463"/>
+    <p:sldId xmlns:r="http://schemas.openxmlformats.org/officeDocument/2006/relationships" id="256" r:id="R9fed807168a741ce"/>
+    <p:sldId xmlns:r="http://schemas.openxmlformats.org/officeDocument/2006/relationships" id="257" r:id="R1f038625173741dd"/>
+    <p:sldId xmlns:r="http://schemas.openxmlformats.org/officeDocument/2006/relationships" id="258" r:id="R2f60270f67a5422e"/>
+    <p:sldId xmlns:r="http://schemas.openxmlformats.org/officeDocument/2006/relationships" id="259" r:id="R075944d1e7824c85"/>
+    <p:sldId xmlns:r="http://schemas.openxmlformats.org/officeDocument/2006/relationships" id="260" r:id="R5e41c9cbb5d644d5"/>
+    <p:sldId xmlns:r="http://schemas.openxmlformats.org/officeDocument/2006/relationships" id="261" r:id="R89c4382fa0da41cd"/>
+    <p:sldId xmlns:r="http://schemas.openxmlformats.org/officeDocument/2006/relationships" id="262" r:id="Ra46d3516f686440c"/>
+    <p:sldId xmlns:r="http://schemas.openxmlformats.org/officeDocument/2006/relationships" id="263" r:id="R516f4418bf3244ec"/>
+    <p:sldId xmlns:r="http://schemas.openxmlformats.org/officeDocument/2006/relationships" id="264" r:id="R570dd4d26bb544e3"/>
+    <p:sldId xmlns:r="http://schemas.openxmlformats.org/officeDocument/2006/relationships" id="265" r:id="Re5d8e35a347a47bf"/>
+    <p:sldId xmlns:r="http://schemas.openxmlformats.org/officeDocument/2006/relationships" id="266" r:id="Re09f77e0db4b421d"/>
+    <p:sldId xmlns:r="http://schemas.openxmlformats.org/officeDocument/2006/relationships" id="267" r:id="R6c14750eed804256"/>
   </p:sldIdLst>
   <p:sldSz cx="18288000" cy="10287000"/>
   <p:notesSz cx="6858000" cy="9144000"/>
@@ -503,7 +503,12 @@
           </a:p>
           <a:p xmlns:a="http://schemas.openxmlformats.org/drawingml/2006/main">
             <a:r>
-              <a:t>- TAP Streamlit application source and locally verified UI/content, 2026-08-12.</a:t>
+              <a:t>- TAP Streamlit application source and locally verified UI/content, 2026-08-13.</a:t>
+            </a:r>
+          </a:p>
+          <a:p xmlns:a="http://schemas.openxmlformats.org/drawingml/2006/main">
+            <a:r>
+              <a:t>- TAP education-evaluation review: docs/TAP_교육평가_검토보고서_v2.md.</a:t>
             </a:r>
           </a:p>
           <a:p xmlns:a="http://schemas.openxmlformats.org/drawingml/2006/main">
@@ -588,12 +593,17 @@
           </a:p>
           <a:p xmlns:a="http://schemas.openxmlformats.org/drawingml/2006/main">
             <a:r>
-              <a:t>- TAP Streamlit application source and locally verified UI/content, 2026-08-12.</a:t>
-            </a:r>
-          </a:p>
-          <a:p xmlns:a="http://schemas.openxmlformats.org/drawingml/2006/main">
-            <a:r>
-              <a:t>- Screenshot: locally verified TAP screen (question-bank.png), 2026-08-12.</a:t>
+              <a:t>- TAP Streamlit application source and locally verified UI/content, 2026-08-13.</a:t>
+            </a:r>
+          </a:p>
+          <a:p xmlns:a="http://schemas.openxmlformats.org/drawingml/2006/main">
+            <a:r>
+              <a:t>- TAP education-evaluation review: docs/TAP_교육평가_검토보고서_v2.md.</a:t>
+            </a:r>
+          </a:p>
+          <a:p xmlns:a="http://schemas.openxmlformats.org/drawingml/2006/main">
+            <a:r>
+              <a:t>- Screenshot: locally verified TAP screen (question-bank.png), 2026-08-13.</a:t>
             </a:r>
           </a:p>
           <a:p xmlns:a="http://schemas.openxmlformats.org/drawingml/2006/main">
@@ -678,7 +688,12 @@
           </a:p>
           <a:p xmlns:a="http://schemas.openxmlformats.org/drawingml/2006/main">
             <a:r>
-              <a:t>- TAP Streamlit application source and locally verified UI/content, 2026-08-12.</a:t>
+              <a:t>- TAP Streamlit application source and locally verified UI/content, 2026-08-13.</a:t>
+            </a:r>
+          </a:p>
+          <a:p xmlns:a="http://schemas.openxmlformats.org/drawingml/2006/main">
+            <a:r>
+              <a:t>- TAP education-evaluation review: docs/TAP_교육평가_검토보고서_v2.md.</a:t>
             </a:r>
           </a:p>
           <a:p xmlns:a="http://schemas.openxmlformats.org/drawingml/2006/main">
@@ -763,7 +778,12 @@
           </a:p>
           <a:p xmlns:a="http://schemas.openxmlformats.org/drawingml/2006/main">
             <a:r>
-              <a:t>- TAP Streamlit application source and locally verified UI/content, 2026-08-12.</a:t>
+              <a:t>- TAP Streamlit application source and locally verified UI/content, 2026-08-13.</a:t>
+            </a:r>
+          </a:p>
+          <a:p xmlns:a="http://schemas.openxmlformats.org/drawingml/2006/main">
+            <a:r>
+              <a:t>- TAP education-evaluation review: docs/TAP_교육평가_검토보고서_v2.md.</a:t>
             </a:r>
           </a:p>
           <a:p xmlns:a="http://schemas.openxmlformats.org/drawingml/2006/main">
@@ -848,7 +868,12 @@
           </a:p>
           <a:p xmlns:a="http://schemas.openxmlformats.org/drawingml/2006/main">
             <a:r>
-              <a:t>- TAP Streamlit application source and locally verified UI/content, 2026-08-12.</a:t>
+              <a:t>- TAP Streamlit application source and locally verified UI/content, 2026-08-13.</a:t>
+            </a:r>
+          </a:p>
+          <a:p xmlns:a="http://schemas.openxmlformats.org/drawingml/2006/main">
+            <a:r>
+              <a:t>- TAP education-evaluation review: docs/TAP_교육평가_검토보고서_v2.md.</a:t>
             </a:r>
           </a:p>
           <a:p xmlns:a="http://schemas.openxmlformats.org/drawingml/2006/main">
@@ -933,7 +958,12 @@
           </a:p>
           <a:p xmlns:a="http://schemas.openxmlformats.org/drawingml/2006/main">
             <a:r>
-              <a:t>- TAP Streamlit application source and locally verified UI/content, 2026-08-12.</a:t>
+              <a:t>- TAP Streamlit application source and locally verified UI/content, 2026-08-13.</a:t>
+            </a:r>
+          </a:p>
+          <a:p xmlns:a="http://schemas.openxmlformats.org/drawingml/2006/main">
+            <a:r>
+              <a:t>- TAP education-evaluation review: docs/TAP_교육평가_검토보고서_v2.md.</a:t>
             </a:r>
           </a:p>
           <a:p xmlns:a="http://schemas.openxmlformats.org/drawingml/2006/main">
@@ -1018,7 +1048,12 @@
           </a:p>
           <a:p xmlns:a="http://schemas.openxmlformats.org/drawingml/2006/main">
             <a:r>
-              <a:t>- TAP Streamlit application source and locally verified UI/content, 2026-08-12.</a:t>
+              <a:t>- TAP Streamlit application source and locally verified UI/content, 2026-08-13.</a:t>
+            </a:r>
+          </a:p>
+          <a:p xmlns:a="http://schemas.openxmlformats.org/drawingml/2006/main">
+            <a:r>
+              <a:t>- TAP education-evaluation review: docs/TAP_교육평가_검토보고서_v2.md.</a:t>
             </a:r>
           </a:p>
           <a:p xmlns:a="http://schemas.openxmlformats.org/drawingml/2006/main">
@@ -1103,7 +1138,12 @@
           </a:p>
           <a:p xmlns:a="http://schemas.openxmlformats.org/drawingml/2006/main">
             <a:r>
-              <a:t>- TAP Streamlit application source and locally verified UI/content, 2026-08-12.</a:t>
+              <a:t>- TAP Streamlit application source and locally verified UI/content, 2026-08-13.</a:t>
+            </a:r>
+          </a:p>
+          <a:p xmlns:a="http://schemas.openxmlformats.org/drawingml/2006/main">
+            <a:r>
+              <a:t>- TAP education-evaluation review: docs/TAP_교육평가_검토보고서_v2.md.</a:t>
             </a:r>
           </a:p>
           <a:p xmlns:a="http://schemas.openxmlformats.org/drawingml/2006/main">
@@ -1188,7 +1228,12 @@
           </a:p>
           <a:p xmlns:a="http://schemas.openxmlformats.org/drawingml/2006/main">
             <a:r>
-              <a:t>- TAP Streamlit application source and locally verified UI/content, 2026-08-12.</a:t>
+              <a:t>- TAP Streamlit application source and locally verified UI/content, 2026-08-13.</a:t>
+            </a:r>
+          </a:p>
+          <a:p xmlns:a="http://schemas.openxmlformats.org/drawingml/2006/main">
+            <a:r>
+              <a:t>- TAP education-evaluation review: docs/TAP_교육평가_검토보고서_v2.md.</a:t>
             </a:r>
           </a:p>
           <a:p xmlns:a="http://schemas.openxmlformats.org/drawingml/2006/main">
@@ -1273,12 +1318,17 @@
           </a:p>
           <a:p xmlns:a="http://schemas.openxmlformats.org/drawingml/2006/main">
             <a:r>
-              <a:t>- TAP Streamlit application source and locally verified UI/content, 2026-08-12.</a:t>
-            </a:r>
-          </a:p>
-          <a:p xmlns:a="http://schemas.openxmlformats.org/drawingml/2006/main">
-            <a:r>
-              <a:t>- Screenshot: locally verified TAP screen (project-setup.png), 2026-08-12.</a:t>
+              <a:t>- TAP Streamlit application source and locally verified UI/content, 2026-08-13.</a:t>
+            </a:r>
+          </a:p>
+          <a:p xmlns:a="http://schemas.openxmlformats.org/drawingml/2006/main">
+            <a:r>
+              <a:t>- TAP education-evaluation review: docs/TAP_교육평가_검토보고서_v2.md.</a:t>
+            </a:r>
+          </a:p>
+          <a:p xmlns:a="http://schemas.openxmlformats.org/drawingml/2006/main">
+            <a:r>
+              <a:t>- Screenshot: locally verified TAP screen (project-setup.png), 2026-08-13.</a:t>
             </a:r>
           </a:p>
           <a:p xmlns:a="http://schemas.openxmlformats.org/drawingml/2006/main">
@@ -1363,12 +1413,17 @@
           </a:p>
           <a:p xmlns:a="http://schemas.openxmlformats.org/drawingml/2006/main">
             <a:r>
-              <a:t>- TAP Streamlit application source and locally verified UI/content, 2026-08-12.</a:t>
-            </a:r>
-          </a:p>
-          <a:p xmlns:a="http://schemas.openxmlformats.org/drawingml/2006/main">
-            <a:r>
-              <a:t>- Screenshot: locally verified TAP screen (assessment.png), 2026-08-12.</a:t>
+              <a:t>- TAP Streamlit application source and locally verified UI/content, 2026-08-13.</a:t>
+            </a:r>
+          </a:p>
+          <a:p xmlns:a="http://schemas.openxmlformats.org/drawingml/2006/main">
+            <a:r>
+              <a:t>- TAP education-evaluation review: docs/TAP_교육평가_검토보고서_v2.md.</a:t>
+            </a:r>
+          </a:p>
+          <a:p xmlns:a="http://schemas.openxmlformats.org/drawingml/2006/main">
+            <a:r>
+              <a:t>- Screenshot: locally verified TAP screen (assessment.png), 2026-08-13.</a:t>
             </a:r>
           </a:p>
           <a:p xmlns:a="http://schemas.openxmlformats.org/drawingml/2006/main">
@@ -1453,12 +1508,17 @@
           </a:p>
           <a:p xmlns:a="http://schemas.openxmlformats.org/drawingml/2006/main">
             <a:r>
-              <a:t>- TAP Streamlit application source and locally verified UI/content, 2026-08-12.</a:t>
-            </a:r>
-          </a:p>
-          <a:p xmlns:a="http://schemas.openxmlformats.org/drawingml/2006/main">
-            <a:r>
-              <a:t>- Screenshot: locally verified TAP screen (organization-report.png), 2026-08-12.</a:t>
+              <a:t>- TAP Streamlit application source and locally verified UI/content, 2026-08-13.</a:t>
+            </a:r>
+          </a:p>
+          <a:p xmlns:a="http://schemas.openxmlformats.org/drawingml/2006/main">
+            <a:r>
+              <a:t>- TAP education-evaluation review: docs/TAP_교육평가_검토보고서_v2.md.</a:t>
+            </a:r>
+          </a:p>
+          <a:p xmlns:a="http://schemas.openxmlformats.org/drawingml/2006/main">
+            <a:r>
+              <a:t>- Screenshot: locally verified TAP screen (organization-report.png), 2026-08-13.</a:t>
             </a:r>
           </a:p>
           <a:p xmlns:a="http://schemas.openxmlformats.org/drawingml/2006/main">
@@ -1694,8 +1754,8 @@
   </p:cSld>
   <p:clrMap bg1="lt1" tx1="dk1" bg2="lt2" tx2="dk2" accent1="accent1" accent2="accent2" accent3="accent3" accent4="accent4" accent5="accent5" accent6="accent6" hlink="hlink" folHlink="folHlink"/>
   <p:sldLayoutIdLst>
-    <p:sldLayoutId xmlns:r="http://schemas.openxmlformats.org/officeDocument/2006/relationships" id="2147483649" r:id="R9ef68fcd43914285"/>
-    <p:sldLayoutId xmlns:r="http://schemas.openxmlformats.org/officeDocument/2006/relationships" id="2147483650" r:id="Rf14f6069e8c543ab"/>
+    <p:sldLayoutId xmlns:r="http://schemas.openxmlformats.org/officeDocument/2006/relationships" id="2147483649" r:id="R1f41691f2f9e4e4f"/>
+    <p:sldLayoutId xmlns:r="http://schemas.openxmlformats.org/officeDocument/2006/relationships" id="2147483650" r:id="R93252bea6e1843d0"/>
   </p:sldLayoutIdLst>
   <p:hf sldNum="0" hdr="0" ftr="0" dt="0"/>
   <p:txStyles>
@@ -2224,7 +2284,7 @@
           <p:nvPr/>
         </p:nvPicPr>
         <p:blipFill>
-          <a:blip xmlns:r="http://schemas.openxmlformats.org/officeDocument/2006/relationships" xmlns:a="http://schemas.openxmlformats.org/drawingml/2006/main" r:embed="R8b66cbf3fd244cf8"/>
+          <a:blip xmlns:r="http://schemas.openxmlformats.org/officeDocument/2006/relationships" xmlns:a="http://schemas.openxmlformats.org/drawingml/2006/main" r:embed="R7edfa00d68f049ab"/>
           <a:srcRect xmlns:a="http://schemas.openxmlformats.org/drawingml/2006/main" l="0" t="-400" r="0" b="-400"/>
           <a:stretch xmlns:a="http://schemas.openxmlformats.org/drawingml/2006/main"/>
         </p:blipFill>
@@ -2247,7 +2307,7 @@
           <p:nvPr/>
         </p:nvPicPr>
         <p:blipFill>
-          <a:blip xmlns:r="http://schemas.openxmlformats.org/officeDocument/2006/relationships" xmlns:a="http://schemas.openxmlformats.org/drawingml/2006/main" r:embed="R63fd2bcca4a74942"/>
+          <a:blip xmlns:r="http://schemas.openxmlformats.org/officeDocument/2006/relationships" xmlns:a="http://schemas.openxmlformats.org/drawingml/2006/main" r:embed="R632a43915a33403c"/>
           <a:srcRect xmlns:a="http://schemas.openxmlformats.org/drawingml/2006/main" l="-2083" t="0" r="-2083" b="0"/>
           <a:stretch xmlns:a="http://schemas.openxmlformats.org/drawingml/2006/main"/>
         </p:blipFill>
@@ -2366,7 +2426,7 @@
                 <a:ea typeface="페이퍼로지 5 Medium"/>
                 <a:cs typeface="페이퍼로지 5 Medium"/>
               </a:rPr>
-              <a:t>회원사 무료 업무행동 진단</a:t>
+              <a:t>회원사 교육 전후 역량평가</a:t>
             </a:r>
           </a:p>
         </p:txBody>
@@ -2424,7 +2484,7 @@
                 <a:ea typeface="페이퍼로지 2 ExtraLight"/>
                 <a:cs typeface="페이퍼로지 2 ExtraLight"/>
               </a:rPr>
-              <a:t>TAP 빠른 사용설명서</a:t>
+              <a:t>TAP 사용설명서</a:t>
             </a:r>
           </a:p>
           <a:p xmlns:a="http://schemas.openxmlformats.org/drawingml/2006/main">
@@ -2448,7 +2508,7 @@
                 <a:ea typeface="페이퍼로지 6 SemiBold"/>
                 <a:cs typeface="페이퍼로지 6 SemiBold"/>
               </a:rPr>
-              <a:t>진단 결과를 교육의 다음 행동으로</a:t>
+              <a:t>교육 전후 변화를 다음 개선으로</a:t>
             </a:r>
           </a:p>
         </p:txBody>
@@ -2880,7 +2940,7 @@
           <p:nvPr/>
         </p:nvPicPr>
         <p:blipFill>
-          <a:blip xmlns:r="http://schemas.openxmlformats.org/officeDocument/2006/relationships" xmlns:a="http://schemas.openxmlformats.org/drawingml/2006/main" r:embed="R5a0fec5106b44346"/>
+          <a:blip xmlns:r="http://schemas.openxmlformats.org/officeDocument/2006/relationships" xmlns:a="http://schemas.openxmlformats.org/drawingml/2006/main" r:embed="R2beb95d6c10142af"/>
           <a:srcRect xmlns:a="http://schemas.openxmlformats.org/drawingml/2006/main" l="-2083" t="0" r="-2083" b="0"/>
           <a:stretch xmlns:a="http://schemas.openxmlformats.org/drawingml/2006/main"/>
         </p:blipFill>
@@ -3058,7 +3118,7 @@
                 <a:ea typeface="페이퍼로지 2 ExtraLight"/>
                 <a:cs typeface="페이퍼로지 2 ExtraLight"/>
               </a:rPr>
-              <a:t>KMA 관리자는 회원사 점수가 아니라</a:t>
+              <a:t>운영 현황을 확인하고</a:t>
             </a:r>
           </a:p>
           <a:p xmlns:a="http://schemas.openxmlformats.org/drawingml/2006/main">
@@ -3082,7 +3142,7 @@
                 <a:ea typeface="페이퍼로지 6 SemiBold"/>
                 <a:cs typeface="페이퍼로지 6 SemiBold"/>
               </a:rPr>
-              <a:t>도구 품질을 관리합니다</a:t>
+              <a:t>문항 품질을 검수합니다</a:t>
             </a:r>
           </a:p>
         </p:txBody>
@@ -3137,7 +3197,7 @@
                 <a:ea typeface="페이퍼로지 3 Light"/>
                 <a:cs typeface="페이퍼로지 3 Light"/>
               </a:rPr>
-              <a:t>문항 버전 · 검수상태 · 과정 매핑 · 감사로그를 관리하며 개인 · 조직 점수는 기본 열람하지 않습니다.</a:t>
+              <a:t>회원사·프로젝트 수치는 운영 목업이며, 배포 문항은행을 검수합니다. 개인·조직 점수는 기본 열람하지 않습니다.</a:t>
             </a:r>
           </a:p>
         </p:txBody>
@@ -3745,7 +3805,7 @@
                 <a:ea typeface="페이퍼로지 5 Medium"/>
                 <a:cs typeface="페이퍼로지 5 Medium"/>
               </a:rPr>
-              <a:t>내려받기</a:t>
+              <a:t>주요 버튼</a:t>
             </a:r>
           </a:p>
         </p:txBody>
@@ -4285,7 +4345,7 @@
           <p:nvPr/>
         </p:nvPicPr>
         <p:blipFill>
-          <a:blip xmlns:r="http://schemas.openxmlformats.org/officeDocument/2006/relationships" xmlns:a="http://schemas.openxmlformats.org/drawingml/2006/main" r:embed="Rda5a4f580adb4ec1"/>
+          <a:blip xmlns:r="http://schemas.openxmlformats.org/officeDocument/2006/relationships" xmlns:a="http://schemas.openxmlformats.org/drawingml/2006/main" r:embed="R881dfa2b459649ca"/>
           <a:stretch xmlns:a="http://schemas.openxmlformats.org/drawingml/2006/main"/>
         </p:blipFill>
         <p:spPr>
@@ -4329,7 +4389,7 @@
           <p:nvPr/>
         </p:nvPicPr>
         <p:blipFill>
-          <a:blip xmlns:r="http://schemas.openxmlformats.org/officeDocument/2006/relationships" xmlns:a="http://schemas.openxmlformats.org/drawingml/2006/main" r:embed="Rb9857adf456847db"/>
+          <a:blip xmlns:r="http://schemas.openxmlformats.org/officeDocument/2006/relationships" xmlns:a="http://schemas.openxmlformats.org/drawingml/2006/main" r:embed="R37ff4497a2dc4211"/>
           <a:srcRect xmlns:a="http://schemas.openxmlformats.org/drawingml/2006/main" l="-2083" t="0" r="-2083" b="0"/>
           <a:stretch xmlns:a="http://schemas.openxmlformats.org/drawingml/2006/main"/>
         </p:blipFill>
@@ -4703,7 +4763,7 @@
                 <a:ea typeface="페이퍼로지 4 Regular"/>
                 <a:cs typeface="페이퍼로지 4 Regular"/>
               </a:rPr>
-              <a:t>새 프로젝트 만들기</a:t>
+              <a:t>사용설명서</a:t>
             </a:r>
           </a:p>
         </p:txBody>
@@ -4910,7 +4970,7 @@
                 <a:ea typeface="페이퍼로지 4 Regular"/>
                 <a:cs typeface="페이퍼로지 4 Regular"/>
               </a:rPr>
-              <a:t>프로젝트 설정 열기</a:t>
+              <a:t>교육평가 프로젝트</a:t>
             </a:r>
           </a:p>
           <a:p xmlns:a="http://schemas.openxmlformats.org/drawingml/2006/main">
@@ -4934,7 +4994,7 @@
                 <a:ea typeface="페이퍼로지 4 Regular"/>
                 <a:cs typeface="페이퍼로지 4 Regular"/>
               </a:rPr>
-              <a:t>진단 참여 화면 열기</a:t>
+              <a:t>사전·사후 검사</a:t>
             </a:r>
           </a:p>
         </p:txBody>
@@ -5165,7 +5225,7 @@
                 <a:ea typeface="페이퍼로지 4 Regular"/>
                 <a:cs typeface="페이퍼로지 4 Regular"/>
               </a:rPr>
-              <a:t>이전 문항 · 진단 초기화</a:t>
+              <a:t>이전 문항</a:t>
             </a:r>
           </a:p>
         </p:txBody>
@@ -5372,7 +5432,7 @@
                 <a:ea typeface="페이퍼로지 4 Regular"/>
                 <a:cs typeface="페이퍼로지 4 Regular"/>
               </a:rPr>
-              <a:t>과정 확인</a:t>
+              <a:t>결과 다시 보기</a:t>
             </a:r>
           </a:p>
           <a:p xmlns:a="http://schemas.openxmlformats.org/drawingml/2006/main">
@@ -5396,7 +5456,7 @@
                 <a:ea typeface="페이퍼로지 4 Regular"/>
                 <a:cs typeface="페이퍼로지 4 Regular"/>
               </a:rPr>
-              <a:t>결과 JSON · 결과 CSV</a:t>
+              <a:t>결과 CSV</a:t>
             </a:r>
           </a:p>
         </p:txBody>
@@ -5603,7 +5663,7 @@
                 <a:ea typeface="페이퍼로지 4 Regular"/>
                 <a:cs typeface="페이퍼로지 4 Regular"/>
               </a:rPr>
-              <a:t>CSV 양식 · 리포트 HTML</a:t>
+              <a:t>인쇄용 리포트 HTML</a:t>
             </a:r>
           </a:p>
           <a:p xmlns:a="http://schemas.openxmlformats.org/drawingml/2006/main">
@@ -6092,7 +6152,7 @@
                 <a:ea typeface="페이퍼로지 4 Regular"/>
                 <a:cs typeface="페이퍼로지 4 Regular"/>
               </a:rPr>
-              <a:t>APPENDIX</a:t>
+              <a:t>REFERENCE</a:t>
             </a:r>
           </a:p>
         </p:txBody>
@@ -6178,7 +6238,7 @@
           <p:nvPr/>
         </p:nvPicPr>
         <p:blipFill>
-          <a:blip xmlns:r="http://schemas.openxmlformats.org/officeDocument/2006/relationships" xmlns:a="http://schemas.openxmlformats.org/drawingml/2006/main" r:embed="Rcba93933f45a420e"/>
+          <a:blip xmlns:r="http://schemas.openxmlformats.org/officeDocument/2006/relationships" xmlns:a="http://schemas.openxmlformats.org/drawingml/2006/main" r:embed="Rc334e960428145ba"/>
           <a:srcRect xmlns:a="http://schemas.openxmlformats.org/drawingml/2006/main" l="-2083" t="0" r="-2083" b="0"/>
           <a:stretch xmlns:a="http://schemas.openxmlformats.org/drawingml/2006/main"/>
         </p:blipFill>
@@ -6201,7 +6261,7 @@
           <p:nvPr/>
         </p:nvPicPr>
         <p:blipFill>
-          <a:blip xmlns:r="http://schemas.openxmlformats.org/officeDocument/2006/relationships" xmlns:a="http://schemas.openxmlformats.org/drawingml/2006/main" r:embed="Rf0e10247930a4925"/>
+          <a:blip xmlns:r="http://schemas.openxmlformats.org/officeDocument/2006/relationships" xmlns:a="http://schemas.openxmlformats.org/drawingml/2006/main" r:embed="R14983dfa91304914"/>
           <a:srcRect xmlns:a="http://schemas.openxmlformats.org/drawingml/2006/main" l="-2083" t="0" r="-2083" b="0"/>
           <a:stretch xmlns:a="http://schemas.openxmlformats.org/drawingml/2006/main"/>
         </p:blipFill>
@@ -6522,7 +6582,7 @@
                 <a:ea typeface="페이퍼로지 2 ExtraLight"/>
                 <a:cs typeface="페이퍼로지 2 ExtraLight"/>
               </a:rPr>
-              <a:t>역할을 고르고 첫 버튼 하나만</a:t>
+              <a:t>역할을 고른 뒤 첫 메뉴에서</a:t>
             </a:r>
           </a:p>
           <a:p xmlns:a="http://schemas.openxmlformats.org/drawingml/2006/main">
@@ -6546,7 +6606,7 @@
                 <a:ea typeface="페이퍼로지 6 SemiBold"/>
                 <a:cs typeface="페이퍼로지 6 SemiBold"/>
               </a:rPr>
-              <a:t>누르면 시작됩니다</a:t>
+              <a:t>시작하세요</a:t>
             </a:r>
           </a:p>
         </p:txBody>
@@ -6601,7 +6661,7 @@
                 <a:ea typeface="페이퍼로지 3 Light"/>
                 <a:cs typeface="페이퍼로지 3 Light"/>
               </a:rPr>
-              <a:t>막히면 ‘처음 사용 안내’로 돌아오고, 아래 순서대로 상태를 확인하세요.</a:t>
+              <a:t>막히면 ‘처음 사용 안내’를 열거나 사이드바의 ‘사용설명서’ PDF를 확인하세요.</a:t>
             </a:r>
           </a:p>
         </p:txBody>
@@ -7041,7 +7101,7 @@
                 <a:ea typeface="페이퍼로지 4 Regular"/>
                 <a:cs typeface="페이퍼로지 4 Regular"/>
               </a:rPr>
-              <a:t>새 프로젝트 만들기</a:t>
+              <a:t>교육평가 프로젝트</a:t>
             </a:r>
           </a:p>
         </p:txBody>
@@ -7151,7 +7211,7 @@
                 <a:ea typeface="페이퍼로지 4 Regular"/>
                 <a:cs typeface="페이퍼로지 4 Regular"/>
               </a:rPr>
-              <a:t>진단 참여</a:t>
+              <a:t>사전·사후 검사</a:t>
             </a:r>
           </a:p>
         </p:txBody>
@@ -7371,7 +7431,7 @@
                 <a:ea typeface="페이퍼로지 4 Regular"/>
                 <a:cs typeface="페이퍼로지 4 Regular"/>
               </a:rPr>
-              <a:t>프로젝트 설정으로 이동</a:t>
+              <a:t>교육평가 설정으로 이동</a:t>
             </a:r>
           </a:p>
         </p:txBody>
@@ -7481,7 +7541,7 @@
                 <a:ea typeface="페이퍼로지 4 Regular"/>
                 <a:cs typeface="페이퍼로지 4 Regular"/>
               </a:rPr>
-              <a:t>응답 완료 여부 확인</a:t>
+              <a:t>전·후 완료 확인</a:t>
             </a:r>
           </a:p>
         </p:txBody>
@@ -7591,7 +7651,7 @@
                 <a:ea typeface="페이퍼로지 4 Regular"/>
                 <a:cs typeface="페이퍼로지 4 Regular"/>
               </a:rPr>
-              <a:t>필수 7열 · 버전 확인</a:t>
+              <a:t>필수 열 · ID · 시점 확인</a:t>
             </a:r>
           </a:p>
         </p:txBody>
@@ -7811,7 +7871,7 @@
           <p:nvPr/>
         </p:nvPicPr>
         <p:blipFill>
-          <a:blip xmlns:r="http://schemas.openxmlformats.org/officeDocument/2006/relationships" xmlns:a="http://schemas.openxmlformats.org/drawingml/2006/main" r:embed="R44be7d70bd5a43e5"/>
+          <a:blip xmlns:r="http://schemas.openxmlformats.org/officeDocument/2006/relationships" xmlns:a="http://schemas.openxmlformats.org/drawingml/2006/main" r:embed="R76adf81a182d4f69"/>
           <a:srcRect xmlns:a="http://schemas.openxmlformats.org/drawingml/2006/main" l="-2083" t="0" r="-2083" b="0"/>
           <a:stretch xmlns:a="http://schemas.openxmlformats.org/drawingml/2006/main"/>
         </p:blipFill>
@@ -7875,7 +7935,7 @@
                 <a:ea typeface="페이퍼로지 2 ExtraLight"/>
                 <a:cs typeface="페이퍼로지 2 ExtraLight"/>
               </a:rPr>
-              <a:t>TAP은 점수를 매기는 도구가 아니라,</a:t>
+              <a:t>TAP은 교육 전후의 변화를</a:t>
             </a:r>
           </a:p>
           <a:p xmlns:a="http://schemas.openxmlformats.org/drawingml/2006/main">
@@ -7899,7 +7959,7 @@
                 <a:ea typeface="페이퍼로지 6 SemiBold"/>
                 <a:cs typeface="페이퍼로지 6 SemiBold"/>
               </a:rPr>
-              <a:t>다음 행동을 정하는 도구입니다</a:t>
+              <a:t>같은 기준으로 확인합니다</a:t>
             </a:r>
           </a:p>
         </p:txBody>
@@ -7954,7 +8014,7 @@
                 <a:ea typeface="페이퍼로지 3 Light"/>
                 <a:cs typeface="페이퍼로지 3 Light"/>
               </a:rPr>
-              <a:t>최근 8주의 실제 업무행동을 확인해 개인에게는 개발 방향을,</a:t>
+              <a:t>교육 전 출발점을 기록하고, 현업 적용 8~10주 후 같은 행동문항으로</a:t>
             </a:r>
           </a:p>
           <a:p xmlns:a="http://schemas.openxmlformats.org/drawingml/2006/main">
@@ -7978,7 +8038,7 @@
                 <a:ea typeface="페이퍼로지 3 Light"/>
                 <a:cs typeface="페이퍼로지 3 Light"/>
               </a:rPr>
-              <a:t>조직에는 공통 교육수요를 제공합니다.</a:t>
+              <a:t>다시 측정해 변화와 현업 적용환경을 확인합니다.</a:t>
             </a:r>
           </a:p>
         </p:txBody>
@@ -8088,7 +8148,7 @@
                 <a:ea typeface="페이퍼로지 5 Medium"/>
                 <a:cs typeface="페이퍼로지 5 Medium"/>
               </a:rPr>
-              <a:t>개인 패턴</a:t>
+              <a:t>사전검사</a:t>
             </a:r>
           </a:p>
         </p:txBody>
@@ -8143,7 +8203,7 @@
                 <a:ea typeface="페이퍼로지 4 Regular"/>
                 <a:cs typeface="페이퍼로지 4 Regular"/>
               </a:rPr>
-              <a:t>행동빈도와</a:t>
+              <a:t>교육 전</a:t>
             </a:r>
           </a:p>
           <a:p xmlns:a="http://schemas.openxmlformats.org/drawingml/2006/main">
@@ -8167,7 +8227,7 @@
                 <a:ea typeface="페이퍼로지 4 Regular"/>
                 <a:cs typeface="페이퍼로지 4 Regular"/>
               </a:rPr>
-              <a:t>개발 후보 확인</a:t>
+              <a:t>출발점 기록</a:t>
             </a:r>
           </a:p>
         </p:txBody>
@@ -8277,7 +8337,7 @@
                 <a:ea typeface="페이퍼로지 5 Medium"/>
                 <a:cs typeface="페이퍼로지 5 Medium"/>
               </a:rPr>
-              <a:t>조직 교육수요</a:t>
+              <a:t>사후검사</a:t>
             </a:r>
           </a:p>
         </p:txBody>
@@ -8332,7 +8392,7 @@
                 <a:ea typeface="페이퍼로지 4 Regular"/>
                 <a:cs typeface="페이퍼로지 4 Regular"/>
               </a:rPr>
-              <a:t>N≥5 익명 집계와</a:t>
+              <a:t>같은 문항으로</a:t>
             </a:r>
           </a:p>
           <a:p xmlns:a="http://schemas.openxmlformats.org/drawingml/2006/main">
@@ -8356,7 +8416,7 @@
                 <a:ea typeface="페이퍼로지 4 Regular"/>
                 <a:cs typeface="페이퍼로지 4 Regular"/>
               </a:rPr>
-              <a:t>목표격차 확인</a:t>
+              <a:t>현업 행동 재측정</a:t>
             </a:r>
           </a:p>
         </p:txBody>
@@ -8521,7 +8581,7 @@
                 <a:ea typeface="페이퍼로지 4 Regular"/>
                 <a:cs typeface="페이퍼로지 4 Regular"/>
               </a:rPr>
-              <a:t>교육 또는 조직환경</a:t>
+              <a:t>짝지은 변화와 전이</a:t>
             </a:r>
           </a:p>
           <a:p xmlns:a="http://schemas.openxmlformats.org/drawingml/2006/main">
@@ -8545,7 +8605,7 @@
                 <a:ea typeface="페이퍼로지 4 Regular"/>
                 <a:cs typeface="페이퍼로지 4 Regular"/>
               </a:rPr>
-              <a:t>개선 결정</a:t>
+              <a:t>조건 확인</a:t>
             </a:r>
           </a:p>
         </p:txBody>
@@ -8907,7 +8967,7 @@
           <p:nvPr/>
         </p:nvPicPr>
         <p:blipFill>
-          <a:blip xmlns:r="http://schemas.openxmlformats.org/officeDocument/2006/relationships" xmlns:a="http://schemas.openxmlformats.org/drawingml/2006/main" r:embed="Rb426ffc7a2f7421f"/>
+          <a:blip xmlns:r="http://schemas.openxmlformats.org/officeDocument/2006/relationships" xmlns:a="http://schemas.openxmlformats.org/drawingml/2006/main" r:embed="R8b604f90197d4327"/>
           <a:srcRect xmlns:a="http://schemas.openxmlformats.org/drawingml/2006/main" l="-2083" t="0" r="-2083" b="0"/>
           <a:stretch xmlns:a="http://schemas.openxmlformats.org/drawingml/2006/main"/>
         </p:blipFill>
@@ -9043,7 +9103,7 @@
                 <a:ea typeface="페이퍼로지 2 ExtraLight"/>
                 <a:cs typeface="페이퍼로지 2 ExtraLight"/>
               </a:rPr>
-              <a:t>세 역할은 서로 다른 화면과</a:t>
+              <a:t>역할마다 필요한 화면과</a:t>
             </a:r>
             <a:endParaRPr sz="4800">
               <a:solidFill>
@@ -9075,7 +9135,7 @@
                 <a:ea typeface="페이퍼로지 6 SemiBold"/>
                 <a:cs typeface="페이퍼로지 6 SemiBold"/>
               </a:rPr>
-              <a:t>데이터만 봅니다</a:t>
+              <a:t>기본 열람범위가 다릅니다</a:t>
             </a:r>
             <a:endParaRPr sz="4800">
               <a:solidFill>
@@ -9138,7 +9198,7 @@
                 <a:ea typeface="페이퍼로지 3 Light"/>
                 <a:cs typeface="페이퍼로지 3 Light"/>
               </a:rPr>
-              <a:t>역할 전환에서 내 역할을 고르면 필요한 메뉴만 표시됩니다.</a:t>
+              <a:t>역할 전환은 데모 화면 안내용이며 실제 운영 권한 인증을 대신하지 않습니다.</a:t>
             </a:r>
           </a:p>
         </p:txBody>
@@ -9303,7 +9363,7 @@
                 <a:ea typeface="페이퍼로지 4 Regular"/>
                 <a:cs typeface="페이퍼로지 4 Regular"/>
               </a:rPr>
-              <a:t>프로젝트 · 조직집계</a:t>
+              <a:t>교육 일정 · 조직 변화</a:t>
             </a:r>
           </a:p>
         </p:txBody>
@@ -9468,7 +9528,7 @@
                 <a:ea typeface="페이퍼로지 4 Regular"/>
                 <a:cs typeface="페이퍼로지 4 Regular"/>
               </a:rPr>
-              <a:t>내 응답 · 내 리포트</a:t>
+              <a:t>사전·사후 · 내 변화</a:t>
             </a:r>
           </a:p>
         </p:txBody>
@@ -9633,7 +9693,7 @@
                 <a:ea typeface="페이퍼로지 4 Regular"/>
                 <a:cs typeface="페이퍼로지 4 Regular"/>
               </a:rPr>
-              <a:t>버전 · 문항 · 과정</a:t>
+              <a:t>운영현황 · 문항검수</a:t>
             </a:r>
           </a:p>
         </p:txBody>
@@ -10531,7 +10591,7 @@
                 <a:ea typeface="페이퍼로지 5 Medium"/>
                 <a:cs typeface="페이퍼로지 5 Medium"/>
               </a:rPr>
-              <a:t>점수 미열람</a:t>
+              <a:t>점수 기본 미열람</a:t>
             </a:r>
           </a:p>
         </p:txBody>
@@ -10789,7 +10849,7 @@
           <p:nvPr/>
         </p:nvPicPr>
         <p:blipFill>
-          <a:blip xmlns:r="http://schemas.openxmlformats.org/officeDocument/2006/relationships" xmlns:a="http://schemas.openxmlformats.org/drawingml/2006/main" r:embed="R5960ab507f124d85"/>
+          <a:blip xmlns:r="http://schemas.openxmlformats.org/officeDocument/2006/relationships" xmlns:a="http://schemas.openxmlformats.org/drawingml/2006/main" r:embed="R26e34f80e16f462b"/>
           <a:srcRect xmlns:a="http://schemas.openxmlformats.org/drawingml/2006/main" l="-2083" t="0" r="-2083" b="0"/>
           <a:stretch xmlns:a="http://schemas.openxmlformats.org/drawingml/2006/main"/>
         </p:blipFill>
@@ -10925,7 +10985,7 @@
                 <a:ea typeface="페이퍼로지 2 ExtraLight"/>
                 <a:cs typeface="페이퍼로지 2 ExtraLight"/>
               </a:rPr>
-              <a:t>결과는 교육과 조직개선 중</a:t>
+              <a:t>결과는 전후 변화와 현업 전이 중</a:t>
             </a:r>
           </a:p>
           <a:p xmlns:a="http://schemas.openxmlformats.org/drawingml/2006/main">
@@ -10949,7 +11009,7 @@
                 <a:ea typeface="페이퍼로지 6 SemiBold"/>
                 <a:cs typeface="페이퍼로지 6 SemiBold"/>
               </a:rPr>
-              <a:t>무엇이 필요한지 가르는 데 씁니다</a:t>
+              <a:t>무엇을 보완할지 정하는 데 씁니다</a:t>
             </a:r>
           </a:p>
         </p:txBody>
@@ -11004,7 +11064,7 @@
                 <a:ea typeface="페이퍼로지 3 Light"/>
                 <a:cs typeface="페이퍼로지 3 Light"/>
               </a:rPr>
-              <a:t>낮은 점수만으로 교육을 추천하지 않습니다.</a:t>
+              <a:t>사후점수만으로 교육효과를 단정하지 않습니다.</a:t>
             </a:r>
           </a:p>
           <a:p xmlns:a="http://schemas.openxmlformats.org/drawingml/2006/main">
@@ -11028,7 +11088,7 @@
                 <a:ea typeface="페이퍼로지 3 Light"/>
                 <a:cs typeface="페이퍼로지 3 Light"/>
               </a:rPr>
-              <a:t>업무환경 · 권한 · 도구 · 프로세스를 함께 봅니다.</a:t>
+              <a:t>적용기회 · 상사지원 · 도구 · 권한을 함께 봅니다.</a:t>
             </a:r>
           </a:p>
         </p:txBody>
@@ -11125,7 +11185,7 @@
                 <a:ea typeface="페이퍼로지 5 Medium"/>
                 <a:cs typeface="페이퍼로지 5 Medium"/>
               </a:rPr>
-              <a:t>개인 리포트 · 본인의 행동 패턴 확인</a:t>
+              <a:t>개인 리포트 · 본인의 사전·사후 변화 확인</a:t>
             </a:r>
           </a:p>
         </p:txBody>
@@ -11180,7 +11240,7 @@
                 <a:ea typeface="페이퍼로지 4 Regular"/>
                 <a:cs typeface="페이퍼로지 4 Regular"/>
               </a:rPr>
-              <a:t>행동빈도 · 개발 후보 · 과정 검토 우선순위</a:t>
+              <a:t>동일 문항의 전후 점수 · 관찰 변화 · 현업 적용환경</a:t>
             </a:r>
           </a:p>
         </p:txBody>
@@ -11277,7 +11337,7 @@
                 <a:ea typeface="페이퍼로지 5 Medium"/>
                 <a:cs typeface="페이퍼로지 5 Medium"/>
               </a:rPr>
-              <a:t>조직 리포트 · 공통 교육수요 확인</a:t>
+              <a:t>조직 리포트 · 짝지어진 집단 변화 확인</a:t>
             </a:r>
           </a:p>
         </p:txBody>
@@ -11332,7 +11392,7 @@
                 <a:ea typeface="페이퍼로지 5 Medium"/>
                 <a:cs typeface="페이퍼로지 5 Medium"/>
               </a:rPr>
-              <a:t>현재</a:t>
+              <a:t>사전</a:t>
             </a:r>
           </a:p>
         </p:txBody>
@@ -11387,7 +11447,7 @@
                 <a:ea typeface="페이퍼로지 4 Regular"/>
                 <a:cs typeface="페이퍼로지 4 Regular"/>
               </a:rPr>
-              <a:t>조직 평균</a:t>
+              <a:t>출발점</a:t>
             </a:r>
           </a:p>
         </p:txBody>
@@ -11442,7 +11502,7 @@
                 <a:ea typeface="페이퍼로지 5 Medium"/>
                 <a:cs typeface="페이퍼로지 5 Medium"/>
               </a:rPr>
-              <a:t>비교</a:t>
+              <a:t>사후</a:t>
             </a:r>
           </a:p>
         </p:txBody>
@@ -11497,7 +11557,7 @@
                 <a:ea typeface="페이퍼로지 4 Regular"/>
                 <a:cs typeface="페이퍼로지 4 Regular"/>
               </a:rPr>
-              <a:t>목표 격차</a:t>
+              <a:t>관찰 변화</a:t>
             </a:r>
           </a:p>
         </p:txBody>
@@ -11552,7 +11612,7 @@
                 <a:ea typeface="페이퍼로지 5 Medium"/>
                 <a:cs typeface="페이퍼로지 5 Medium"/>
               </a:rPr>
-              <a:t>판단</a:t>
+              <a:t>맥락</a:t>
             </a:r>
           </a:p>
         </p:txBody>
@@ -11607,7 +11667,7 @@
                 <a:ea typeface="페이퍼로지 4 Regular"/>
                 <a:cs typeface="페이퍼로지 4 Regular"/>
               </a:rPr>
-              <a:t>교육 · 환경</a:t>
+              <a:t>적용환경</a:t>
             </a:r>
           </a:p>
         </p:txBody>
@@ -11772,7 +11832,7 @@
                 <a:ea typeface="페이퍼로지 4 Regular"/>
                 <a:cs typeface="페이퍼로지 4 Regular"/>
               </a:rPr>
-              <a:t>시스템 요인이 주원인이면 교육 추천을 중단하고 조직개선을 먼저 검토합니다.</a:t>
+              <a:t>비교집단이 없으면 교육의 인과효과가 아니라 ‘교육 전후 관찰된 변화’로 표현합니다.</a:t>
             </a:r>
           </a:p>
         </p:txBody>
@@ -12031,7 +12091,7 @@
                 <a:ea typeface="페이퍼로지 6 SemiBold"/>
                 <a:cs typeface="페이퍼로지 6 SemiBold"/>
               </a:rPr>
-              <a:t>결과 해석의 두 갈래</a:t>
+              <a:t>교육 전후 해석의 흐름</a:t>
             </a:r>
           </a:p>
         </p:txBody>
@@ -12443,7 +12503,7 @@
                 <a:ea typeface="페이퍼로지 6 SemiBold"/>
                 <a:cs typeface="페이퍼로지 6 SemiBold"/>
               </a:rPr>
-              <a:t>행동</a:t>
+              <a:t>사전</a:t>
             </a:r>
           </a:p>
           <a:p xmlns:a="http://schemas.openxmlformats.org/drawingml/2006/main">
@@ -12467,7 +12527,7 @@
                 <a:ea typeface="페이퍼로지 6 SemiBold"/>
                 <a:cs typeface="페이퍼로지 6 SemiBold"/>
               </a:rPr>
-              <a:t>패턴</a:t>
+              <a:t>출발점</a:t>
             </a:r>
           </a:p>
         </p:txBody>
@@ -12530,7 +12590,7 @@
                 <a:ea typeface="페이퍼로지 6 SemiBold"/>
                 <a:cs typeface="페이퍼로지 6 SemiBold"/>
               </a:rPr>
-              <a:t>과정</a:t>
+              <a:t>전이</a:t>
             </a:r>
           </a:p>
           <a:p xmlns:a="http://schemas.openxmlformats.org/drawingml/2006/main">
@@ -12554,7 +12614,7 @@
                 <a:ea typeface="페이퍼로지 6 SemiBold"/>
                 <a:cs typeface="페이퍼로지 6 SemiBold"/>
               </a:rPr>
-              <a:t>검토</a:t>
+              <a:t>조건</a:t>
             </a:r>
           </a:p>
         </p:txBody>
@@ -12623,7 +12683,7 @@
                 <a:ea typeface="페이퍼로지 6 SemiBold"/>
                 <a:cs typeface="페이퍼로지 6 SemiBold"/>
               </a:rPr>
-              <a:t>공통</a:t>
+              <a:t>사후</a:t>
             </a:r>
           </a:p>
           <a:p xmlns:a="http://schemas.openxmlformats.org/drawingml/2006/main">
@@ -12647,7 +12707,7 @@
                 <a:ea typeface="페이퍼로지 6 SemiBold"/>
                 <a:cs typeface="페이퍼로지 6 SemiBold"/>
               </a:rPr>
-              <a:t>수요</a:t>
+              <a:t>재측정</a:t>
             </a:r>
           </a:p>
         </p:txBody>
@@ -12734,7 +12794,7 @@
                 <a:ea typeface="페이퍼로지 6 SemiBold"/>
                 <a:cs typeface="페이퍼로지 6 SemiBold"/>
               </a:rPr>
-              <a:t>계획</a:t>
+              <a:t>보완</a:t>
             </a:r>
           </a:p>
         </p:txBody>
@@ -12803,7 +12863,7 @@
                 <a:ea typeface="페이퍼로지 6 SemiBold"/>
                 <a:cs typeface="페이퍼로지 6 SemiBold"/>
               </a:rPr>
-              <a:t>원인</a:t>
+              <a:t>짝지은</a:t>
             </a:r>
           </a:p>
           <a:p xmlns:a="http://schemas.openxmlformats.org/drawingml/2006/main">
@@ -12827,7 +12887,7 @@
                 <a:ea typeface="페이퍼로지 6 SemiBold"/>
                 <a:cs typeface="페이퍼로지 6 SemiBold"/>
               </a:rPr>
-              <a:t>확인</a:t>
+              <a:t>변화</a:t>
             </a:r>
           </a:p>
         </p:txBody>
@@ -12985,7 +13045,7 @@
                 <a:ea typeface="페이퍼로지 5 Medium"/>
                 <a:cs typeface="페이퍼로지 5 Medium"/>
               </a:rPr>
-              <a:t>개인 순위가 아니라 다음 행동을 정하는 진단</a:t>
+              <a:t>개인 순위가 아니라 같은 사람의 전후 변화를 확인</a:t>
             </a:r>
           </a:p>
         </p:txBody>
@@ -13021,7 +13081,7 @@
           <p:nvPr/>
         </p:nvPicPr>
         <p:blipFill>
-          <a:blip xmlns:r="http://schemas.openxmlformats.org/officeDocument/2006/relationships" xmlns:a="http://schemas.openxmlformats.org/drawingml/2006/main" r:embed="Raa6cbfdf2be24b93"/>
+          <a:blip xmlns:r="http://schemas.openxmlformats.org/officeDocument/2006/relationships" xmlns:a="http://schemas.openxmlformats.org/drawingml/2006/main" r:embed="Rde75508f8b0e4732"/>
           <a:srcRect xmlns:a="http://schemas.openxmlformats.org/drawingml/2006/main" l="-2083" t="0" r="-2083" b="0"/>
           <a:stretch xmlns:a="http://schemas.openxmlformats.org/drawingml/2006/main"/>
         </p:blipFill>
@@ -13164,7 +13224,7 @@
                 <a:ea typeface="페이퍼로지 3 Light"/>
                 <a:cs typeface="페이퍼로지 3 Light"/>
               </a:rPr>
-              <a:t>교육개발용 자기보고 진단입니다. 아래 여섯 가지 경계를 지켜 사용합니다.</a:t>
+              <a:t>교육개발용 자기보고 전후 평가입니다. 아래 여섯 가지 경계를 지켜 사용합니다.</a:t>
             </a:r>
           </a:p>
         </p:txBody>
@@ -13730,7 +13790,7 @@
                 <a:ea typeface="페이퍼로지 5 Medium"/>
                 <a:cs typeface="페이퍼로지 5 Medium"/>
               </a:rPr>
-              <a:t>공유는 선택</a:t>
+              <a:t>개인결과 공유는 선택</a:t>
             </a:r>
           </a:p>
         </p:txBody>
@@ -13992,7 +14052,7 @@
                 <a:ea typeface="페이퍼로지 4 Regular"/>
                 <a:cs typeface="페이퍼로지 4 Regular"/>
               </a:rPr>
-              <a:t>소수집단 보호</a:t>
+              <a:t>공개 최소기준일 뿐</a:t>
             </a:r>
           </a:p>
         </p:txBody>
@@ -14144,7 +14204,7 @@
                 <a:ea typeface="페이퍼로지 5 Medium"/>
                 <a:cs typeface="페이퍼로지 5 Medium"/>
               </a:rPr>
-              <a:t>실데이터 금지</a:t>
+              <a:t>공개 데모 실데이터 금지</a:t>
             </a:r>
           </a:p>
         </p:txBody>
@@ -14199,7 +14259,7 @@
                 <a:ea typeface="페이퍼로지 4 Regular"/>
                 <a:cs typeface="페이퍼로지 4 Regular"/>
               </a:rPr>
-              <a:t>공개 데모는 세션 저장</a:t>
+              <a:t>세션에만 임시 저장</a:t>
             </a:r>
           </a:p>
         </p:txBody>
@@ -14351,7 +14411,7 @@
                 <a:ea typeface="페이퍼로지 5 Medium"/>
                 <a:cs typeface="페이퍼로지 5 Medium"/>
               </a:rPr>
-              <a:t>실증 전 단계</a:t>
+              <a:t>인과효과 아님</a:t>
             </a:r>
           </a:p>
         </p:txBody>
@@ -14406,7 +14466,7 @@
                 <a:ea typeface="페이퍼로지 4 Regular"/>
                 <a:cs typeface="페이퍼로지 4 Regular"/>
               </a:rPr>
-              <a:t>인지면접 · 파일럿 필요</a:t>
+              <a:t>비교집단 없으면 관찰 변화</a:t>
             </a:r>
           </a:p>
         </p:txBody>
@@ -14768,7 +14828,7 @@
           <p:nvPr/>
         </p:nvPicPr>
         <p:blipFill>
-          <a:blip xmlns:r="http://schemas.openxmlformats.org/officeDocument/2006/relationships" xmlns:a="http://schemas.openxmlformats.org/drawingml/2006/main" r:embed="R2a41ddb894634187"/>
+          <a:blip xmlns:r="http://schemas.openxmlformats.org/officeDocument/2006/relationships" xmlns:a="http://schemas.openxmlformats.org/drawingml/2006/main" r:embed="Ra73b3daf828c495b"/>
           <a:srcRect xmlns:a="http://schemas.openxmlformats.org/drawingml/2006/main" l="-2083" t="0" r="-2083" b="0"/>
           <a:stretch xmlns:a="http://schemas.openxmlformats.org/drawingml/2006/main"/>
         </p:blipFill>
@@ -14791,7 +14851,7 @@
           <p:nvPr/>
         </p:nvPicPr>
         <p:blipFill>
-          <a:blip xmlns:r="http://schemas.openxmlformats.org/officeDocument/2006/relationships" xmlns:a="http://schemas.openxmlformats.org/drawingml/2006/main" r:embed="Rabe3cf17e7e843c1"/>
+          <a:blip xmlns:r="http://schemas.openxmlformats.org/officeDocument/2006/relationships" xmlns:a="http://schemas.openxmlformats.org/drawingml/2006/main" r:embed="R804ef4a7f396442a"/>
           <a:srcRect xmlns:a="http://schemas.openxmlformats.org/drawingml/2006/main" l="-2083" t="0" r="-2083" b="0"/>
           <a:stretch xmlns:a="http://schemas.openxmlformats.org/drawingml/2006/main"/>
         </p:blipFill>
@@ -15112,7 +15172,7 @@
                 <a:ea typeface="페이퍼로지 2 ExtraLight"/>
                 <a:cs typeface="페이퍼로지 2 ExtraLight"/>
               </a:rPr>
-              <a:t>실제 사용은 네 단계로</a:t>
+              <a:t>설정 - 사전 - 교육·현업 -</a:t>
             </a:r>
           </a:p>
           <a:p xmlns:a="http://schemas.openxmlformats.org/drawingml/2006/main">
@@ -15136,7 +15196,7 @@
                 <a:ea typeface="페이퍼로지 6 SemiBold"/>
                 <a:cs typeface="페이퍼로지 6 SemiBold"/>
               </a:rPr>
-              <a:t>끝납니다</a:t>
+              <a:t>사후·리포트 순서입니다</a:t>
             </a:r>
           </a:p>
         </p:txBody>
@@ -15191,7 +15251,7 @@
                 <a:ea typeface="페이퍼로지 3 Light"/>
                 <a:cs typeface="페이퍼로지 3 Light"/>
               </a:rPr>
-              <a:t>앞부분의 원칙을 이해했다면, 이제 아래 순서만 따라가면 됩니다.</a:t>
+              <a:t>교육 전 출발점을 기록하고 현업 적용 뒤 같은 기준으로 다시 측정합니다.</a:t>
             </a:r>
           </a:p>
         </p:txBody>
@@ -15576,7 +15636,7 @@
                 <a:ea typeface="페이퍼로지 5 Medium"/>
                 <a:cs typeface="페이퍼로지 5 Medium"/>
               </a:rPr>
-              <a:t>프로젝트</a:t>
+              <a:t>교육·평가 설정</a:t>
             </a:r>
           </a:p>
         </p:txBody>
@@ -15631,7 +15691,7 @@
                 <a:ea typeface="페이퍼로지 4 Regular"/>
                 <a:cs typeface="페이퍼로지 4 Regular"/>
               </a:rPr>
-              <a:t>대상 · 기간 · 역량</a:t>
+              <a:t>교육일 · 전후 기간 · 역량</a:t>
             </a:r>
           </a:p>
         </p:txBody>
@@ -15686,7 +15746,7 @@
                 <a:ea typeface="페이퍼로지 5 Medium"/>
                 <a:cs typeface="페이퍼로지 5 Medium"/>
               </a:rPr>
-              <a:t>행동 응답</a:t>
+              <a:t>사전검사</a:t>
             </a:r>
           </a:p>
         </p:txBody>
@@ -15741,7 +15801,7 @@
                 <a:ea typeface="페이퍼로지 4 Regular"/>
                 <a:cs typeface="페이퍼로지 4 Regular"/>
               </a:rPr>
-              <a:t>최근 8주 · 1~5</a:t>
+              <a:t>교육 전 최근 8주</a:t>
             </a:r>
           </a:p>
         </p:txBody>
@@ -15796,7 +15856,7 @@
                 <a:ea typeface="페이퍼로지 5 Medium"/>
                 <a:cs typeface="페이퍼로지 5 Medium"/>
               </a:rPr>
-              <a:t>개인 결과</a:t>
+              <a:t>교육·현업 적용</a:t>
             </a:r>
           </a:p>
         </p:txBody>
@@ -15851,7 +15911,7 @@
                 <a:ea typeface="페이퍼로지 4 Regular"/>
                 <a:cs typeface="페이퍼로지 4 Regular"/>
               </a:rPr>
-              <a:t>본인 패턴 확인</a:t>
+              <a:t>적용기회 확보</a:t>
             </a:r>
           </a:p>
         </p:txBody>
@@ -15906,7 +15966,7 @@
                 <a:ea typeface="페이퍼로지 5 Medium"/>
                 <a:cs typeface="페이퍼로지 5 Medium"/>
               </a:rPr>
-              <a:t>조직 집계</a:t>
+              <a:t>사후검사</a:t>
             </a:r>
           </a:p>
         </p:txBody>
@@ -15961,7 +16021,7 @@
                 <a:ea typeface="페이퍼로지 4 Regular"/>
                 <a:cs typeface="페이퍼로지 4 Regular"/>
               </a:rPr>
-              <a:t>N≥5 익명 결과</a:t>
+              <a:t>같은 문항 · 최근 8주</a:t>
             </a:r>
           </a:p>
         </p:txBody>
@@ -16016,7 +16076,7 @@
                 <a:ea typeface="페이퍼로지 5 Medium"/>
                 <a:cs typeface="페이퍼로지 5 Medium"/>
               </a:rPr>
-              <a:t>원인 확인</a:t>
+              <a:t>짝지은 리포트</a:t>
             </a:r>
           </a:p>
         </p:txBody>
@@ -16071,7 +16131,7 @@
                 <a:ea typeface="페이퍼로지 4 Regular"/>
                 <a:cs typeface="페이퍼로지 4 Regular"/>
               </a:rPr>
-              <a:t>교육 · 환경 구분</a:t>
+              <a:t>동일 ID · 동일 버전</a:t>
             </a:r>
           </a:p>
         </p:txBody>
@@ -16126,7 +16186,7 @@
                 <a:ea typeface="페이퍼로지 5 Medium"/>
                 <a:cs typeface="페이퍼로지 5 Medium"/>
               </a:rPr>
-              <a:t>다음 행동</a:t>
+              <a:t>전이 해석</a:t>
             </a:r>
           </a:p>
         </p:txBody>
@@ -16181,7 +16241,7 @@
                 <a:ea typeface="페이퍼로지 4 Regular"/>
                 <a:cs typeface="페이퍼로지 4 Regular"/>
               </a:rPr>
-              <a:t>과정 또는 개선</a:t>
+              <a:t>교육 보완 · 환경 개선</a:t>
             </a:r>
           </a:p>
         </p:txBody>
@@ -16474,7 +16534,7 @@
                 <a:ea typeface="페이퍼로지 4 Regular"/>
                 <a:cs typeface="페이퍼로지 4 Regular"/>
               </a:rPr>
-              <a:t>1. 설정</a:t>
+              <a:t>1. 설정·사전</a:t>
             </a:r>
           </a:p>
           <a:p xmlns:a="http://schemas.openxmlformats.org/drawingml/2006/main">
@@ -16498,7 +16558,7 @@
                 <a:ea typeface="페이퍼로지 6 SemiBold"/>
                 <a:cs typeface="페이퍼로지 6 SemiBold"/>
               </a:rPr>
-              <a:t>교육담당자</a:t>
+              <a:t>교육담당자·참여자</a:t>
             </a:r>
           </a:p>
         </p:txBody>
@@ -16569,7 +16629,7 @@
                 <a:ea typeface="페이퍼로지 4 Regular"/>
                 <a:cs typeface="페이퍼로지 4 Regular"/>
               </a:rPr>
-              <a:t>2. 응답</a:t>
+              <a:t>2. 교육</a:t>
             </a:r>
           </a:p>
           <a:p xmlns:a="http://schemas.openxmlformats.org/drawingml/2006/main">
@@ -16593,7 +16653,7 @@
                 <a:ea typeface="페이퍼로지 6 SemiBold"/>
                 <a:cs typeface="페이퍼로지 6 SemiBold"/>
               </a:rPr>
-              <a:t>참여자</a:t>
+              <a:t>현업 적용</a:t>
             </a:r>
           </a:p>
         </p:txBody>
@@ -16686,7 +16746,7 @@
                 <a:ea typeface="페이퍼로지 4 Regular"/>
                 <a:cs typeface="페이퍼로지 4 Regular"/>
               </a:rPr>
-              <a:t>4단계 사용</a:t>
+              <a:t>전후 평가</a:t>
             </a:r>
           </a:p>
         </p:txBody>
@@ -16757,7 +16817,7 @@
                 <a:ea typeface="페이퍼로지 4 Regular"/>
                 <a:cs typeface="페이퍼로지 4 Regular"/>
               </a:rPr>
-              <a:t>3–4. 결과</a:t>
+              <a:t>3–4. 사후</a:t>
             </a:r>
           </a:p>
           <a:p xmlns:a="http://schemas.openxmlformats.org/drawingml/2006/main">
@@ -16781,7 +16841,7 @@
                 <a:ea typeface="페이퍼로지 6 SemiBold"/>
                 <a:cs typeface="페이퍼로지 6 SemiBold"/>
               </a:rPr>
-              <a:t>해석 · 결정</a:t>
+              <a:t>변화 · 전이</a:t>
             </a:r>
           </a:p>
         </p:txBody>
@@ -16909,7 +16969,7 @@
           <p:nvPr/>
         </p:nvPicPr>
         <p:blipFill>
-          <a:blip xmlns:r="http://schemas.openxmlformats.org/officeDocument/2006/relationships" xmlns:a="http://schemas.openxmlformats.org/drawingml/2006/main" r:embed="Rc914676c7b004d72"/>
+          <a:blip xmlns:r="http://schemas.openxmlformats.org/officeDocument/2006/relationships" xmlns:a="http://schemas.openxmlformats.org/drawingml/2006/main" r:embed="R6dd34fe127614ae1"/>
           <a:srcRect xmlns:a="http://schemas.openxmlformats.org/drawingml/2006/main" l="-2083" t="0" r="-2083" b="0"/>
           <a:stretch xmlns:a="http://schemas.openxmlformats.org/drawingml/2006/main"/>
         </p:blipFill>
@@ -17087,7 +17147,7 @@
                 <a:ea typeface="페이퍼로지 2 ExtraLight"/>
                 <a:cs typeface="페이퍼로지 2 ExtraLight"/>
               </a:rPr>
-              <a:t>교육담당자는 프로젝트를 구성한 뒤</a:t>
+              <a:t>교육담당자는 교육과 검사 일정을</a:t>
             </a:r>
           </a:p>
           <a:p xmlns:a="http://schemas.openxmlformats.org/drawingml/2006/main">
@@ -17111,7 +17171,7 @@
                 <a:ea typeface="페이퍼로지 6 SemiBold"/>
                 <a:cs typeface="페이퍼로지 6 SemiBold"/>
               </a:rPr>
-              <a:t>참여 화면을 확인합니다</a:t>
+              <a:t>먼저 고정합니다</a:t>
             </a:r>
           </a:p>
         </p:txBody>
@@ -17166,7 +17226,7 @@
                 <a:ea typeface="페이퍼로지 3 Light"/>
                 <a:cs typeface="페이퍼로지 3 Light"/>
               </a:rPr>
-              <a:t>진단 프로젝트에서 기본정보 · 역량 · 임시 목표 · 추천조건을 한 번에 저장합니다.</a:t>
+              <a:t>교육명 · 교육일 · 사전/사후 기간 · 측정역량을 한 번에 저장합니다. 사후는 교육 8~10주 후를 권장합니다.</a:t>
             </a:r>
           </a:p>
         </p:txBody>
@@ -17415,7 +17475,31 @@
                 <a:ea typeface="페이퍼로지 4 Regular"/>
                 <a:cs typeface="페이퍼로지 4 Regular"/>
               </a:rPr>
-              <a:t>프로젝트명 · 대상 · 기간</a:t>
+              <a:t>프로젝트명 · 교육과정명</a:t>
+            </a:r>
+          </a:p>
+          <a:p xmlns:a="http://schemas.openxmlformats.org/drawingml/2006/main">
+            <a:pPr algn="l">
+              <a:buNone/>
+              <a:defRPr>
+                <a:solidFill>
+                  <a:srgbClr val="1E2324"/>
+                </a:solidFill>
+                <a:latin typeface="페이퍼로지 4 Regular"/>
+                <a:ea typeface="페이퍼로지 4 Regular"/>
+                <a:cs typeface="페이퍼로지 4 Regular"/>
+              </a:defRPr>
+            </a:pPr>
+            <a:r>
+              <a:rPr sz="1100">
+                <a:solidFill>
+                  <a:srgbClr val="1E2324"/>
+                </a:solidFill>
+                <a:latin typeface="페이퍼로지 4 Regular"/>
+                <a:ea typeface="페이퍼로지 4 Regular"/>
+                <a:cs typeface="페이퍼로지 4 Regular"/>
+              </a:rPr>
+              <a:t>응답 대상</a:t>
             </a:r>
           </a:p>
         </p:txBody>
@@ -17567,7 +17651,7 @@
                 <a:ea typeface="페이퍼로지 4 Regular"/>
                 <a:cs typeface="페이퍼로지 4 Regular"/>
               </a:rPr>
-              <a:t>기본 + 선택역량 최대 4개</a:t>
+              <a:t>교육일 · 교육 전후 검사기간</a:t>
             </a:r>
           </a:p>
         </p:txBody>
@@ -17677,7 +17761,31 @@
                 <a:ea typeface="페이퍼로지 4 Regular"/>
                 <a:cs typeface="페이퍼로지 4 Regular"/>
               </a:rPr>
-              <a:t>목표 · 우선역량 · 격차 원인</a:t>
+              <a:t>현재 열 검사</a:t>
+            </a:r>
+          </a:p>
+          <a:p xmlns:a="http://schemas.openxmlformats.org/drawingml/2006/main">
+            <a:pPr algn="l">
+              <a:buNone/>
+              <a:defRPr>
+                <a:solidFill>
+                  <a:srgbClr val="1E2324"/>
+                </a:solidFill>
+                <a:latin typeface="페이퍼로지 4 Regular"/>
+                <a:ea typeface="페이퍼로지 4 Regular"/>
+                <a:cs typeface="페이퍼로지 4 Regular"/>
+              </a:defRPr>
+            </a:pPr>
+            <a:r>
+              <a:rPr sz="1000">
+                <a:solidFill>
+                  <a:srgbClr val="1E2324"/>
+                </a:solidFill>
+                <a:latin typeface="페이퍼로지 4 Regular"/>
+                <a:ea typeface="페이퍼로지 4 Regular"/>
+                <a:cs typeface="페이퍼로지 4 Regular"/>
+              </a:rPr>
+              <a:t>측정역량</a:t>
             </a:r>
           </a:p>
         </p:txBody>
@@ -17926,7 +18034,7 @@
                 <a:ea typeface="페이퍼로지 4 Regular"/>
                 <a:cs typeface="페이퍼로지 4 Regular"/>
               </a:rPr>
-              <a:t>새 프로젝트 만들기</a:t>
+              <a:t>교육평가 프로젝트 만들기</a:t>
             </a:r>
           </a:p>
         </p:txBody>
@@ -18078,7 +18186,7 @@
                 <a:ea typeface="페이퍼로지 4 Regular"/>
                 <a:cs typeface="페이퍼로지 4 Regular"/>
               </a:rPr>
-              <a:t>설정 저장 후 참여자 화면 확인</a:t>
+              <a:t>설정 저장 후 사전검사 확인</a:t>
             </a:r>
           </a:p>
         </p:txBody>
@@ -18188,7 +18296,31 @@
                 <a:ea typeface="페이퍼로지 4 Regular"/>
                 <a:cs typeface="페이퍼로지 4 Regular"/>
               </a:rPr>
-              <a:t>참여자 미리보기</a:t>
+              <a:t>교육 전·후</a:t>
+            </a:r>
+          </a:p>
+          <a:p xmlns:a="http://schemas.openxmlformats.org/drawingml/2006/main">
+            <a:pPr algn="l">
+              <a:buNone/>
+              <a:defRPr>
+                <a:solidFill>
+                  <a:srgbClr val="1E2324"/>
+                </a:solidFill>
+                <a:latin typeface="페이퍼로지 4 Regular"/>
+                <a:ea typeface="페이퍼로지 4 Regular"/>
+                <a:cs typeface="페이퍼로지 4 Regular"/>
+              </a:defRPr>
+            </a:pPr>
+            <a:r>
+              <a:rPr sz="1100">
+                <a:solidFill>
+                  <a:srgbClr val="1E2324"/>
+                </a:solidFill>
+                <a:latin typeface="페이퍼로지 4 Regular"/>
+                <a:ea typeface="페이퍼로지 4 Regular"/>
+                <a:cs typeface="페이퍼로지 4 Regular"/>
+              </a:rPr>
+              <a:t>역량평가 선택</a:t>
             </a:r>
           </a:p>
         </p:txBody>
@@ -18314,7 +18446,7 @@
           <p:nvPr/>
         </p:nvPicPr>
         <p:blipFill>
-          <a:blip xmlns:r="http://schemas.openxmlformats.org/officeDocument/2006/relationships" xmlns:a="http://schemas.openxmlformats.org/drawingml/2006/main" r:embed="R9fb51371cb8a4a95"/>
+          <a:blip xmlns:r="http://schemas.openxmlformats.org/officeDocument/2006/relationships" xmlns:a="http://schemas.openxmlformats.org/drawingml/2006/main" r:embed="R90641c02e9fb4f43"/>
           <a:stretch xmlns:a="http://schemas.openxmlformats.org/drawingml/2006/main"/>
         </p:blipFill>
         <p:spPr>
@@ -18450,7 +18582,7 @@
           <p:nvPr/>
         </p:nvPicPr>
         <p:blipFill>
-          <a:blip xmlns:r="http://schemas.openxmlformats.org/officeDocument/2006/relationships" xmlns:a="http://schemas.openxmlformats.org/drawingml/2006/main" r:embed="R574484fa17064c01"/>
+          <a:blip xmlns:r="http://schemas.openxmlformats.org/officeDocument/2006/relationships" xmlns:a="http://schemas.openxmlformats.org/drawingml/2006/main" r:embed="R8123ead290ae4fd7"/>
           <a:srcRect xmlns:a="http://schemas.openxmlformats.org/drawingml/2006/main" l="-2083" t="0" r="-2083" b="0"/>
           <a:stretch xmlns:a="http://schemas.openxmlformats.org/drawingml/2006/main"/>
         </p:blipFill>
@@ -18628,7 +18760,7 @@
                 <a:ea typeface="페이퍼로지 2 ExtraLight"/>
                 <a:cs typeface="페이퍼로지 2 ExtraLight"/>
               </a:rPr>
-              <a:t>참여자는 최근 8주 행동에</a:t>
+              <a:t>참여자는 사전·사후에</a:t>
             </a:r>
           </a:p>
           <a:p xmlns:a="http://schemas.openxmlformats.org/drawingml/2006/main">
@@ -18652,7 +18784,7 @@
                 <a:ea typeface="페이퍼로지 6 SemiBold"/>
                 <a:cs typeface="페이퍼로지 6 SemiBold"/>
               </a:rPr>
-              <a:t>한 문항씩 답합니다</a:t>
+              <a:t>같은 기준으로 답합니다</a:t>
             </a:r>
           </a:p>
         </p:txBody>
@@ -18707,7 +18839,7 @@
                 <a:ea typeface="페이퍼로지 3 Light"/>
                 <a:cs typeface="페이퍼로지 3 Light"/>
               </a:rPr>
-              <a:t>좋아 보이는 답이 아니라 실제 행동 빈도를 선택합니다. 수행 기회 없음은 미응답과 다르게 처리됩니다.</a:t>
+              <a:t>현재 검사단계를 먼저 확인합니다. 두 시점 모두 최근 8주 실제 행동을 답하고, 사후에는 현업 적용환경도 응답합니다.</a:t>
             </a:r>
           </a:p>
         </p:txBody>
@@ -18956,7 +19088,7 @@
                 <a:ea typeface="페이퍼로지 4 Regular"/>
                 <a:cs typeface="페이퍼로지 4 Regular"/>
               </a:rPr>
-              <a:t>수행 기회 없음 또는 1~5 선택</a:t>
+              <a:t>사전검사 · 사후검사 단계 확인</a:t>
             </a:r>
           </a:p>
         </p:txBody>
@@ -19108,7 +19240,7 @@
                 <a:ea typeface="페이퍼로지 4 Regular"/>
                 <a:cs typeface="페이퍼로지 4 Regular"/>
               </a:rPr>
-              <a:t>저장하고 다음</a:t>
+              <a:t>수행 기회 없음 또는 1~5</a:t>
             </a:r>
           </a:p>
         </p:txBody>
@@ -19218,7 +19350,7 @@
                 <a:ea typeface="페이퍼로지 4 Regular"/>
                 <a:cs typeface="페이퍼로지 4 Regular"/>
               </a:rPr>
-              <a:t>마지막 문항에서 결과 보기</a:t>
+              <a:t>현업전이 환경 확인 · 결과 보기</a:t>
             </a:r>
           </a:p>
         </p:txBody>
@@ -19619,7 +19751,7 @@
                 <a:ea typeface="페이퍼로지 4 Regular"/>
                 <a:cs typeface="페이퍼로지 4 Regular"/>
               </a:rPr>
-              <a:t>진단 초기화 → 초기화 확인</a:t>
+              <a:t>교육 전·후 검사 초기화 → 확인</a:t>
             </a:r>
           </a:p>
         </p:txBody>
@@ -19729,7 +19861,7 @@
                 <a:ea typeface="페이퍼로지 4 Regular"/>
                 <a:cs typeface="페이퍼로지 4 Regular"/>
               </a:rPr>
-              <a:t>내 리포트 · 과정 확인</a:t>
+              <a:t>내 변화 리포트</a:t>
             </a:r>
           </a:p>
         </p:txBody>
@@ -19855,7 +19987,7 @@
           <p:nvPr/>
         </p:nvPicPr>
         <p:blipFill>
-          <a:blip xmlns:r="http://schemas.openxmlformats.org/officeDocument/2006/relationships" xmlns:a="http://schemas.openxmlformats.org/drawingml/2006/main" r:embed="Rb6bfe1111c564dbd"/>
+          <a:blip xmlns:r="http://schemas.openxmlformats.org/officeDocument/2006/relationships" xmlns:a="http://schemas.openxmlformats.org/drawingml/2006/main" r:embed="R3919f162c8054e66"/>
           <a:stretch xmlns:a="http://schemas.openxmlformats.org/drawingml/2006/main"/>
         </p:blipFill>
         <p:spPr>
@@ -19991,7 +20123,7 @@
           <p:nvPr/>
         </p:nvPicPr>
         <p:blipFill>
-          <a:blip xmlns:r="http://schemas.openxmlformats.org/officeDocument/2006/relationships" xmlns:a="http://schemas.openxmlformats.org/drawingml/2006/main" r:embed="R16e42a8f67fe4656"/>
+          <a:blip xmlns:r="http://schemas.openxmlformats.org/officeDocument/2006/relationships" xmlns:a="http://schemas.openxmlformats.org/drawingml/2006/main" r:embed="R1e37c79d64f94702"/>
           <a:srcRect xmlns:a="http://schemas.openxmlformats.org/drawingml/2006/main" l="-2083" t="0" r="-2083" b="0"/>
           <a:stretch xmlns:a="http://schemas.openxmlformats.org/drawingml/2006/main"/>
         </p:blipFill>
@@ -20169,7 +20301,7 @@
                 <a:ea typeface="페이퍼로지 2 ExtraLight"/>
                 <a:cs typeface="페이퍼로지 2 ExtraLight"/>
               </a:rPr>
-              <a:t>익명 CSV를 올리면</a:t>
+              <a:t>동일 익명 ID의 전후 결과로</a:t>
             </a:r>
           </a:p>
           <a:p xmlns:a="http://schemas.openxmlformats.org/drawingml/2006/main">
@@ -20193,7 +20325,7 @@
                 <a:ea typeface="페이퍼로지 6 SemiBold"/>
                 <a:cs typeface="페이퍼로지 6 SemiBold"/>
               </a:rPr>
-              <a:t>A4 조직 리포트가 완성됩니다</a:t>
+              <a:t>짝지은 변화 리포트를 만듭니다</a:t>
             </a:r>
           </a:p>
         </p:txBody>
@@ -20248,7 +20380,7 @@
                 <a:ea typeface="페이퍼로지 3 Light"/>
                 <a:cs typeface="페이퍼로지 3 Light"/>
               </a:rPr>
-              <a:t>업로드가 없으면 예시 데이터가 표시됩니다. 실제 개인정보 · 기밀자료는 공개 데모에 올리지 마세요.</a:t>
+              <a:t>동일 참여자 · 동일 역량 · 동일 버전의 사전/사후 유효점수만 비교합니다. N&lt;5 결과는 보호됩니다.</a:t>
             </a:r>
           </a:p>
         </p:txBody>
@@ -20497,7 +20629,7 @@
                 <a:ea typeface="페이퍼로지 4 Regular"/>
                 <a:cs typeface="페이퍼로지 4 Regular"/>
               </a:rPr>
-              <a:t>CSV 양식 내려받기</a:t>
+              <a:t>사전·사후 CSV 양식 내려받기</a:t>
             </a:r>
           </a:p>
         </p:txBody>
@@ -20649,7 +20781,7 @@
                 <a:ea typeface="페이퍼로지 4 Regular"/>
                 <a:cs typeface="페이퍼로지 4 Regular"/>
               </a:rPr>
-              <a:t>필수 7열로 익명 결과 작성</a:t>
+              <a:t>익명 조직결과 CSV 업로드</a:t>
             </a:r>
           </a:p>
         </p:txBody>
@@ -20759,7 +20891,7 @@
                 <a:ea typeface="페이퍼로지 4 Regular"/>
                 <a:cs typeface="페이퍼로지 4 Regular"/>
               </a:rPr>
-              <a:t>익명 조직결과 CSV 업로드</a:t>
+              <a:t>동일 ID · pre/post · 버전 확인</a:t>
             </a:r>
           </a:p>
         </p:txBody>
@@ -21396,7 +21528,7 @@
           <p:nvPr/>
         </p:nvPicPr>
         <p:blipFill>
-          <a:blip xmlns:r="http://schemas.openxmlformats.org/officeDocument/2006/relationships" xmlns:a="http://schemas.openxmlformats.org/drawingml/2006/main" r:embed="R9a4cf989df00426e"/>
+          <a:blip xmlns:r="http://schemas.openxmlformats.org/officeDocument/2006/relationships" xmlns:a="http://schemas.openxmlformats.org/drawingml/2006/main" r:embed="Rc317fa18d51b4555"/>
           <a:stretch xmlns:a="http://schemas.openxmlformats.org/drawingml/2006/main"/>
         </p:blipFill>
         <p:spPr>

</xml_diff>